<commit_message>
docs: rebuild executive briefing charts and notes from dashboard-ready.csv
Charts now plot the dataset directly (queue SLA, HITL split, AHT by
content type, daily SLA trend, per-agent speed vs quality). Speaker
notes and slide copy reflect what the data shows: the Sep 24-27 dip
is a high-risk mix shift at flat volume, the capacity gap is 4 FTEs,
and new-hire errors are mostly false positives. Recovery figures are
labelled as targets rather than projections.

Co-Authored-By: Claude Opus 5.5 <noreply@anthropic.com>
Claude-Session: https://claude.ai/code/session_018U5KYsVR1k6QhPhM8y4R3g
</commit_message>
<xml_diff>
--- a/docs/presentation/ApexTrust_Content_Moderation_Executive_Briefing.pptx
+++ b/docs/presentation/ApexTrust_Content_Moderation_Executive_Briefing.pptx
@@ -112,28 +112,28 @@
   <p:extLst>
     <p:ext uri="{521415D9-36F7-43E2-AB2F-B90AF26B5E84}">
       <p14:sectionLst xmlns:p14="http://schemas.microsoft.com/office/powerpoint/2010/main">
-        <p14:section name="Bottom Line Up Front" id="{5920db87-6d97-e1b4-145e-4269b2871857}">
+        <p14:section name="Bottom Line Up Front" id="{9229cc15-7323-0bdb-bc1b-1d781536a0b7}">
           <p14:sldIdLst>
             <p14:sldId id="256"/>
           </p14:sldIdLst>
         </p14:section>
-        <p14:section name="What?" id="{6bd36762-37ff-ef70-3488-3cb040cf6459}">
+        <p14:section name="What?" id="{0ae2e285-cb90-8f2b-6103-1837450968da}">
           <p14:sldIdLst>
             <p14:sldId id="257"/>
           </p14:sldIdLst>
         </p14:section>
-        <p14:section name="So What?" id="{50b1afca-f899-a42c-32eb-6fa9ac0dba89}">
+        <p14:section name="So What?" id="{a032e58d-f481-5009-39bb-d346c099750a}">
           <p14:sldIdLst>
             <p14:sldId id="258"/>
             <p14:sldId id="259"/>
           </p14:sldIdLst>
         </p14:section>
-        <p14:section name="Now What?" id="{8bed15f5-4d13-e4f6-2194-f6cca67080cc}">
+        <p14:section name="Now What?" id="{bf2a3e70-fe64-808c-a0e7-f3cace16e9f7}">
           <p14:sldIdLst>
             <p14:sldId id="260"/>
           </p14:sldIdLst>
         </p14:section>
-        <p14:section name="Appendix" id="{9b00e03c-9515-ea35-c11b-943ba5252b90}">
+        <p14:section name="Appendix" id="{0cf4be7b-3695-73ca-b4c3-36bc20fddfe5}">
           <p14:sldIdLst>
             <p14:sldId id="261"/>
           </p14:sldIdLst>
@@ -583,16 +583,16 @@
                 <c:formatCode>General</c:formatCode>
                 <c:ptCount val="4"/>
                 <c:pt idx="0">
-                  <c:v>28.4</c:v>
+                  <c:v>15.8</c:v>
                 </c:pt>
                 <c:pt idx="1">
-                  <c:v>54.2</c:v>
+                  <c:v>31.9</c:v>
                 </c:pt>
                 <c:pt idx="2">
-                  <c:v>148.6</c:v>
+                  <c:v>107.7</c:v>
                 </c:pt>
                 <c:pt idx="3">
-                  <c:v>242.1</c:v>
+                  <c:v>189.6</c:v>
                 </c:pt>
               </c:numCache>
             </c:numRef>
@@ -673,7 +673,7 @@
         <c:axId val="2094734552"/>
         <c:scaling>
           <c:orientation val="minMax"/>
-          <c:max val="280"/>
+          <c:max val="220"/>
           <c:min val="0"/>
         </c:scaling>
         <c:delete val="1"/>
@@ -746,15 +746,13 @@
           <c:layoutTarget val="inner"/>
           <c:xMode val="edge"/>
           <c:yMode val="edge"/>
-          <c:x val="0.04"/>
-          <c:y val="0.12"/>
-          <c:w val="0.92"/>
+          <c:x val="0.09"/>
+          <c:y val="0.1"/>
+          <c:w val="0.88"/>
           <c:h val="0.72"/>
         </c:manualLayout>
       </c:layout>
-      <c:barChart>
-        <c:barDir val="col"/>
-        <c:grouping val="clustered"/>
+      <c:lineChart>
         <c:varyColors val="0"/>
         <c:ser>
           <c:idx val="0"/>
@@ -765,20 +763,27 @@
               <c:strCache>
                 <c:ptCount val="1"/>
                 <c:pt idx="0">
-                  <c:v>Items/day</c:v>
+                  <c:v>Daily SLA %</c:v>
                 </c:pt>
               </c:strCache>
             </c:strRef>
           </c:tx>
           <c:spPr>
             <a:solidFill>
-              <a:srgbClr val="A99FC0"/>
+              <a:srgbClr val="492C73"/>
             </a:solidFill>
+            <a:ln w="25400" cap="flat">
+              <a:solidFill>
+                <a:srgbClr val="492C73"/>
+              </a:solidFill>
+              <a:prstDash val="solid,dash"/>
+              <a:round/>
+            </a:ln>
             <a:effectLst/>
           </c:spPr>
           <c:invertIfNegative val="0"/>
           <c:dLbls>
-            <c:numFmt formatCode="0&quot;/day&quot;" sourceLinked="0"/>
+            <c:numFmt formatCode="#,##0" sourceLinked="0"/>
             <c:txPr>
               <a:bodyPr/>
               <a:lstStyle/>
@@ -786,7 +791,7 @@
                 <a:pPr>
                   <a:defRPr b="0" i="0" strike="noStrike" sz="1200" u="none">
                     <a:solidFill>
-                      <a:srgbClr val="231833"/>
+                      <a:srgbClr val="000000"/>
                     </a:solidFill>
                     <a:latin typeface="+mn-lt"/>
                   </a:defRPr>
@@ -794,60 +799,125 @@
               </a:p>
             </c:txPr>
             <c:showLegendKey val="0"/>
-            <c:showVal val="1"/>
+            <c:showVal val="0"/>
             <c:showCatName val="0"/>
             <c:showSerName val="0"/>
             <c:showPercent val="0"/>
             <c:showBubbleSize val="0"/>
             <c:showLeaderLines val="0"/>
           </c:dLbls>
-          <c:dPt>
-            <c:idx val="0"/>
-            <c:invertIfNegative val="0"/>
-            <c:bubble3D val="0"/>
+          <c:marker>
+            <c:symbol val="none"/>
+            <c:size val="6"/>
             <c:spPr>
               <a:solidFill>
-                <a:srgbClr val="A99FC0"/>
+                <a:srgbClr val="492C73"/>
               </a:solidFill>
+              <a:ln w="9525" cap="flat">
+                <a:solidFill>
+                  <a:srgbClr val="492C73"/>
+                </a:solidFill>
+                <a:prstDash val="solid"/>
+                <a:round/>
+              </a:ln>
               <a:effectLst/>
             </c:spPr>
-          </c:dPt>
-          <c:dPt>
-            <c:idx val="1"/>
-            <c:invertIfNegative val="0"/>
-            <c:bubble3D val="0"/>
-            <c:spPr>
-              <a:solidFill>
-                <a:srgbClr val="C8475A"/>
-              </a:solidFill>
-              <a:effectLst/>
-            </c:spPr>
-          </c:dPt>
-          <c:dPt>
-            <c:idx val="2"/>
-            <c:invertIfNegative val="0"/>
-            <c:bubble3D val="0"/>
-            <c:spPr>
-              <a:solidFill>
-                <a:srgbClr val="66548C"/>
-              </a:solidFill>
-              <a:effectLst/>
-            </c:spPr>
-          </c:dPt>
+          </c:marker>
           <c:cat>
             <c:multiLvlStrRef>
-              <c:f>Sheet1!$A$2:$A$4</c:f>
+              <c:f>Sheet1!$A$2:$A$31</c:f>
               <c:multiLvlStrCache>
-                <c:ptCount val="3"/>
+                <c:ptCount val="30"/>
                 <c:lvl>
                   <c:pt idx="0">
-                    <c:v>Days 1–17 (steady)</c:v>
+                    <c:v>Sep 6</c:v>
                   </c:pt>
                   <c:pt idx="1">
-                    <c:v>Days 18–21 (viral)</c:v>
+                    <c:v>Sep 7</c:v>
                   </c:pt>
                   <c:pt idx="2">
-                    <c:v>Days 22–30 (burn-off)</c:v>
+                    <c:v>Sep 8</c:v>
+                  </c:pt>
+                  <c:pt idx="3">
+                    <c:v>Sep 9</c:v>
+                  </c:pt>
+                  <c:pt idx="4">
+                    <c:v>Sep 10</c:v>
+                  </c:pt>
+                  <c:pt idx="5">
+                    <c:v>Sep 11</c:v>
+                  </c:pt>
+                  <c:pt idx="6">
+                    <c:v>Sep 12</c:v>
+                  </c:pt>
+                  <c:pt idx="7">
+                    <c:v>Sep 13</c:v>
+                  </c:pt>
+                  <c:pt idx="8">
+                    <c:v>Sep 14</c:v>
+                  </c:pt>
+                  <c:pt idx="9">
+                    <c:v>Sep 15</c:v>
+                  </c:pt>
+                  <c:pt idx="10">
+                    <c:v>Sep 16</c:v>
+                  </c:pt>
+                  <c:pt idx="11">
+                    <c:v>Sep 17</c:v>
+                  </c:pt>
+                  <c:pt idx="12">
+                    <c:v>Sep 18</c:v>
+                  </c:pt>
+                  <c:pt idx="13">
+                    <c:v>Sep 19</c:v>
+                  </c:pt>
+                  <c:pt idx="14">
+                    <c:v>Sep 20</c:v>
+                  </c:pt>
+                  <c:pt idx="15">
+                    <c:v>Sep 21</c:v>
+                  </c:pt>
+                  <c:pt idx="16">
+                    <c:v>Sep 22</c:v>
+                  </c:pt>
+                  <c:pt idx="17">
+                    <c:v>Sep 23</c:v>
+                  </c:pt>
+                  <c:pt idx="18">
+                    <c:v>Sep 24</c:v>
+                  </c:pt>
+                  <c:pt idx="19">
+                    <c:v>Sep 25</c:v>
+                  </c:pt>
+                  <c:pt idx="20">
+                    <c:v>Sep 26</c:v>
+                  </c:pt>
+                  <c:pt idx="21">
+                    <c:v>Sep 27</c:v>
+                  </c:pt>
+                  <c:pt idx="22">
+                    <c:v>Sep 28</c:v>
+                  </c:pt>
+                  <c:pt idx="23">
+                    <c:v>Sep 29</c:v>
+                  </c:pt>
+                  <c:pt idx="24">
+                    <c:v>Sep 30</c:v>
+                  </c:pt>
+                  <c:pt idx="25">
+                    <c:v>Oct 1</c:v>
+                  </c:pt>
+                  <c:pt idx="26">
+                    <c:v>Oct 2</c:v>
+                  </c:pt>
+                  <c:pt idx="27">
+                    <c:v>Oct 3</c:v>
+                  </c:pt>
+                  <c:pt idx="28">
+                    <c:v>Oct 4</c:v>
+                  </c:pt>
+                  <c:pt idx="29">
+                    <c:v>Oct 5</c:v>
                   </c:pt>
                 </c:lvl>
               </c:multiLvlStrCache>
@@ -855,25 +925,377 @@
           </c:cat>
           <c:val>
             <c:numRef>
-              <c:f>Sheet1!$B$2:$B$4</c:f>
+              <c:f>Sheet1!$B$2:$B$31</c:f>
               <c:numCache>
                 <c:formatCode>General</c:formatCode>
-                <c:ptCount val="3"/>
+                <c:ptCount val="30"/>
                 <c:pt idx="0">
-                  <c:v>80</c:v>
+                  <c:v>85.1</c:v>
                 </c:pt>
                 <c:pt idx="1">
-                  <c:v>188</c:v>
+                  <c:v>80.6</c:v>
                 </c:pt>
                 <c:pt idx="2">
-                  <c:v>102</c:v>
+                  <c:v>83.7</c:v>
+                </c:pt>
+                <c:pt idx="3">
+                  <c:v>81.7</c:v>
+                </c:pt>
+                <c:pt idx="4">
+                  <c:v>80.7</c:v>
+                </c:pt>
+                <c:pt idx="5">
+                  <c:v>82.5</c:v>
+                </c:pt>
+                <c:pt idx="6">
+                  <c:v>81.7</c:v>
+                </c:pt>
+                <c:pt idx="7">
+                  <c:v>93.8</c:v>
+                </c:pt>
+                <c:pt idx="8">
+                  <c:v>85.4</c:v>
+                </c:pt>
+                <c:pt idx="9">
+                  <c:v>88.1</c:v>
+                </c:pt>
+                <c:pt idx="10">
+                  <c:v>90.9</c:v>
+                </c:pt>
+                <c:pt idx="11">
+                  <c:v>85.6</c:v>
+                </c:pt>
+                <c:pt idx="12">
+                  <c:v>87</c:v>
+                </c:pt>
+                <c:pt idx="13">
+                  <c:v>75.5</c:v>
+                </c:pt>
+                <c:pt idx="14">
+                  <c:v>88.6</c:v>
+                </c:pt>
+                <c:pt idx="15">
+                  <c:v>75.3</c:v>
+                </c:pt>
+                <c:pt idx="16">
+                  <c:v>84.9</c:v>
+                </c:pt>
+                <c:pt idx="17">
+                  <c:v>87</c:v>
+                </c:pt>
+                <c:pt idx="18">
+                  <c:v>44.3</c:v>
+                </c:pt>
+                <c:pt idx="19">
+                  <c:v>38.5</c:v>
+                </c:pt>
+                <c:pt idx="20">
+                  <c:v>37.8</c:v>
+                </c:pt>
+                <c:pt idx="21">
+                  <c:v>44.8</c:v>
+                </c:pt>
+                <c:pt idx="22">
+                  <c:v>67.6</c:v>
+                </c:pt>
+                <c:pt idx="23">
+                  <c:v>86</c:v>
+                </c:pt>
+                <c:pt idx="24">
+                  <c:v>82.2</c:v>
+                </c:pt>
+                <c:pt idx="25">
+                  <c:v>89.5</c:v>
+                </c:pt>
+                <c:pt idx="26">
+                  <c:v>87.4</c:v>
+                </c:pt>
+                <c:pt idx="27">
+                  <c:v>84.2</c:v>
+                </c:pt>
+                <c:pt idx="28">
+                  <c:v>80.4</c:v>
+                </c:pt>
+                <c:pt idx="29">
+                  <c:v>78.7</c:v>
                 </c:pt>
               </c:numCache>
             </c:numRef>
           </c:val>
+          <c:smooth val="0"/>
+        </c:ser>
+        <c:ser>
+          <c:idx val="1"/>
+          <c:order val="1"/>
+          <c:tx>
+            <c:strRef>
+              <c:f>Sheet1!$C$1</c:f>
+              <c:strCache>
+                <c:ptCount val="1"/>
+                <c:pt idx="0">
+                  <c:v>95% target</c:v>
+                </c:pt>
+              </c:strCache>
+            </c:strRef>
+          </c:tx>
+          <c:spPr>
+            <a:solidFill>
+              <a:srgbClr val="74BF04"/>
+            </a:solidFill>
+            <a:ln w="25400" cap="flat">
+              <a:solidFill>
+                <a:srgbClr val="74BF04"/>
+              </a:solidFill>
+              <a:prstDash val="solid,dash"/>
+              <a:round/>
+            </a:ln>
+            <a:effectLst/>
+          </c:spPr>
+          <c:invertIfNegative val="0"/>
+          <c:dLbls>
+            <c:numFmt formatCode="#,##0" sourceLinked="0"/>
+            <c:txPr>
+              <a:bodyPr/>
+              <a:lstStyle/>
+              <a:p>
+                <a:pPr>
+                  <a:defRPr b="0" i="0" strike="noStrike" sz="1200" u="none">
+                    <a:solidFill>
+                      <a:srgbClr val="000000"/>
+                    </a:solidFill>
+                    <a:latin typeface="+mn-lt"/>
+                  </a:defRPr>
+                </a:pPr>
+              </a:p>
+            </c:txPr>
+            <c:showLegendKey val="0"/>
+            <c:showVal val="0"/>
+            <c:showCatName val="0"/>
+            <c:showSerName val="0"/>
+            <c:showPercent val="0"/>
+            <c:showBubbleSize val="0"/>
+            <c:showLeaderLines val="0"/>
+          </c:dLbls>
+          <c:marker>
+            <c:symbol val="none"/>
+            <c:size val="6"/>
+            <c:spPr>
+              <a:solidFill>
+                <a:srgbClr val="74BF04"/>
+              </a:solidFill>
+              <a:ln w="9525" cap="flat">
+                <a:solidFill>
+                  <a:srgbClr val="74BF04"/>
+                </a:solidFill>
+                <a:prstDash val="solid"/>
+                <a:round/>
+              </a:ln>
+              <a:effectLst/>
+            </c:spPr>
+          </c:marker>
+          <c:cat>
+            <c:multiLvlStrRef>
+              <c:f>Sheet1!$A$2:$A$31</c:f>
+              <c:multiLvlStrCache>
+                <c:ptCount val="30"/>
+                <c:lvl>
+                  <c:pt idx="0">
+                    <c:v>Sep 6</c:v>
+                  </c:pt>
+                  <c:pt idx="1">
+                    <c:v>Sep 7</c:v>
+                  </c:pt>
+                  <c:pt idx="2">
+                    <c:v>Sep 8</c:v>
+                  </c:pt>
+                  <c:pt idx="3">
+                    <c:v>Sep 9</c:v>
+                  </c:pt>
+                  <c:pt idx="4">
+                    <c:v>Sep 10</c:v>
+                  </c:pt>
+                  <c:pt idx="5">
+                    <c:v>Sep 11</c:v>
+                  </c:pt>
+                  <c:pt idx="6">
+                    <c:v>Sep 12</c:v>
+                  </c:pt>
+                  <c:pt idx="7">
+                    <c:v>Sep 13</c:v>
+                  </c:pt>
+                  <c:pt idx="8">
+                    <c:v>Sep 14</c:v>
+                  </c:pt>
+                  <c:pt idx="9">
+                    <c:v>Sep 15</c:v>
+                  </c:pt>
+                  <c:pt idx="10">
+                    <c:v>Sep 16</c:v>
+                  </c:pt>
+                  <c:pt idx="11">
+                    <c:v>Sep 17</c:v>
+                  </c:pt>
+                  <c:pt idx="12">
+                    <c:v>Sep 18</c:v>
+                  </c:pt>
+                  <c:pt idx="13">
+                    <c:v>Sep 19</c:v>
+                  </c:pt>
+                  <c:pt idx="14">
+                    <c:v>Sep 20</c:v>
+                  </c:pt>
+                  <c:pt idx="15">
+                    <c:v>Sep 21</c:v>
+                  </c:pt>
+                  <c:pt idx="16">
+                    <c:v>Sep 22</c:v>
+                  </c:pt>
+                  <c:pt idx="17">
+                    <c:v>Sep 23</c:v>
+                  </c:pt>
+                  <c:pt idx="18">
+                    <c:v>Sep 24</c:v>
+                  </c:pt>
+                  <c:pt idx="19">
+                    <c:v>Sep 25</c:v>
+                  </c:pt>
+                  <c:pt idx="20">
+                    <c:v>Sep 26</c:v>
+                  </c:pt>
+                  <c:pt idx="21">
+                    <c:v>Sep 27</c:v>
+                  </c:pt>
+                  <c:pt idx="22">
+                    <c:v>Sep 28</c:v>
+                  </c:pt>
+                  <c:pt idx="23">
+                    <c:v>Sep 29</c:v>
+                  </c:pt>
+                  <c:pt idx="24">
+                    <c:v>Sep 30</c:v>
+                  </c:pt>
+                  <c:pt idx="25">
+                    <c:v>Oct 1</c:v>
+                  </c:pt>
+                  <c:pt idx="26">
+                    <c:v>Oct 2</c:v>
+                  </c:pt>
+                  <c:pt idx="27">
+                    <c:v>Oct 3</c:v>
+                  </c:pt>
+                  <c:pt idx="28">
+                    <c:v>Oct 4</c:v>
+                  </c:pt>
+                  <c:pt idx="29">
+                    <c:v>Oct 5</c:v>
+                  </c:pt>
+                </c:lvl>
+              </c:multiLvlStrCache>
+            </c:multiLvlStrRef>
+          </c:cat>
+          <c:val>
+            <c:numRef>
+              <c:f>Sheet1!$C$2:$C$31</c:f>
+              <c:numCache>
+                <c:formatCode>General</c:formatCode>
+                <c:ptCount val="30"/>
+                <c:pt idx="0">
+                  <c:v>95</c:v>
+                </c:pt>
+                <c:pt idx="1">
+                  <c:v>95</c:v>
+                </c:pt>
+                <c:pt idx="2">
+                  <c:v>95</c:v>
+                </c:pt>
+                <c:pt idx="3">
+                  <c:v>95</c:v>
+                </c:pt>
+                <c:pt idx="4">
+                  <c:v>95</c:v>
+                </c:pt>
+                <c:pt idx="5">
+                  <c:v>95</c:v>
+                </c:pt>
+                <c:pt idx="6">
+                  <c:v>95</c:v>
+                </c:pt>
+                <c:pt idx="7">
+                  <c:v>95</c:v>
+                </c:pt>
+                <c:pt idx="8">
+                  <c:v>95</c:v>
+                </c:pt>
+                <c:pt idx="9">
+                  <c:v>95</c:v>
+                </c:pt>
+                <c:pt idx="10">
+                  <c:v>95</c:v>
+                </c:pt>
+                <c:pt idx="11">
+                  <c:v>95</c:v>
+                </c:pt>
+                <c:pt idx="12">
+                  <c:v>95</c:v>
+                </c:pt>
+                <c:pt idx="13">
+                  <c:v>95</c:v>
+                </c:pt>
+                <c:pt idx="14">
+                  <c:v>95</c:v>
+                </c:pt>
+                <c:pt idx="15">
+                  <c:v>95</c:v>
+                </c:pt>
+                <c:pt idx="16">
+                  <c:v>95</c:v>
+                </c:pt>
+                <c:pt idx="17">
+                  <c:v>95</c:v>
+                </c:pt>
+                <c:pt idx="18">
+                  <c:v>95</c:v>
+                </c:pt>
+                <c:pt idx="19">
+                  <c:v>95</c:v>
+                </c:pt>
+                <c:pt idx="20">
+                  <c:v>95</c:v>
+                </c:pt>
+                <c:pt idx="21">
+                  <c:v>95</c:v>
+                </c:pt>
+                <c:pt idx="22">
+                  <c:v>95</c:v>
+                </c:pt>
+                <c:pt idx="23">
+                  <c:v>95</c:v>
+                </c:pt>
+                <c:pt idx="24">
+                  <c:v>95</c:v>
+                </c:pt>
+                <c:pt idx="25">
+                  <c:v>95</c:v>
+                </c:pt>
+                <c:pt idx="26">
+                  <c:v>95</c:v>
+                </c:pt>
+                <c:pt idx="27">
+                  <c:v>95</c:v>
+                </c:pt>
+                <c:pt idx="28">
+                  <c:v>95</c:v>
+                </c:pt>
+                <c:pt idx="29">
+                  <c:v>95</c:v>
+                </c:pt>
+              </c:numCache>
+            </c:numRef>
+          </c:val>
+          <c:smooth val="0"/>
         </c:ser>
         <c:dLbls>
-          <c:numFmt formatCode="0&quot;/day&quot;" sourceLinked="0"/>
+          <c:numFmt formatCode="#,##0" sourceLinked="0"/>
           <c:txPr>
             <a:bodyPr/>
             <a:lstStyle/>
@@ -881,7 +1303,7 @@
               <a:pPr>
                 <a:defRPr b="0" i="0" strike="noStrike" sz="1200" u="none">
                   <a:solidFill>
-                    <a:srgbClr val="231833"/>
+                    <a:srgbClr val="000000"/>
                   </a:solidFill>
                   <a:latin typeface="+mn-lt"/>
                 </a:defRPr>
@@ -889,25 +1311,24 @@
             </a:p>
           </c:txPr>
           <c:showLegendKey val="0"/>
-          <c:showVal val="1"/>
+          <c:showVal val="0"/>
           <c:showCatName val="0"/>
           <c:showSerName val="0"/>
           <c:showPercent val="0"/>
           <c:showBubbleSize val="0"/>
           <c:showLeaderLines val="0"/>
         </c:dLbls>
-        <c:gapWidth val="70"/>
-        <c:overlap val="0"/>
+        <c:marker val="1"/>
         <c:axId val="2094734554"/>
         <c:axId val="2094734552"/>
         <c:axId val="2094734556"/>
-      </c:barChart>
+      </c:lineChart>
       <c:catAx>
         <c:axId val="2094734554"/>
         <c:scaling>
           <c:orientation val="minMax"/>
         </c:scaling>
-        <c:delete val="0"/>
+        <c:delete val="1"/>
         <c:axPos val="b"/>
         <c:numFmt formatCode="General" sourceLinked="1"/>
         <c:majorTickMark val="out"/>
@@ -947,12 +1368,23 @@
         <c:axId val="2094734552"/>
         <c:scaling>
           <c:orientation val="minMax"/>
-          <c:max val="210"/>
+          <c:max val="100"/>
           <c:min val="0"/>
         </c:scaling>
-        <c:delete val="1"/>
+        <c:delete val="0"/>
         <c:axPos val="l"/>
-        <c:numFmt formatCode="General" sourceLinked="0"/>
+        <c:majorGridlines>
+          <c:spPr>
+            <a:ln w="9525" cap="flat">
+              <a:solidFill>
+                <a:srgbClr val="E3DFEA"/>
+              </a:solidFill>
+              <a:prstDash val="solid"/>
+              <a:round/>
+            </a:ln>
+          </c:spPr>
+        </c:majorGridlines>
+        <c:numFmt formatCode="0&quot;%&quot;" sourceLinked="0"/>
         <c:majorTickMark val="out"/>
         <c:minorTickMark val="none"/>
         <c:tickLblPos val="nextTo"/>
@@ -983,6 +1415,7 @@
         <c:crossAx val="2094734554"/>
         <c:crosses val="autoZero"/>
         <c:crossBetween val="between"/>
+        <c:majorUnit val="25"/>
       </c:valAx>
       <c:spPr>
         <a:noFill/>
@@ -1028,7 +1461,7 @@
               <c:strCache>
                 <c:ptCount val="1"/>
                 <c:pt idx="0">
-                  <c:v>Senior (AGENT_12–15)</c:v>
+                  <c:v>Senior (6mo+)</c:v>
                 </c:pt>
               </c:strCache>
             </c:strRef>
@@ -1044,7 +1477,7 @@
           </c:spPr>
           <c:marker>
             <c:symbol val="circle"/>
-            <c:size val="16"/>
+            <c:size val="12"/>
             <c:spPr>
               <a:solidFill>
                 <a:srgbClr val="74BF04"/>
@@ -1061,36 +1494,108 @@
           </c:marker>
           <c:xVal>
             <c:numRef>
-              <c:f>Sheet1!$A$2:$A$4</c:f>
+              <c:f>Sheet1!$A$2:$A$16</c:f>
               <c:numCache>
                 <c:formatCode>General</c:formatCode>
-                <c:ptCount val="3"/>
+                <c:ptCount val="15"/>
                 <c:pt idx="0">
-                  <c:v>38</c:v>
+                  <c:v>76.5</c:v>
                 </c:pt>
                 <c:pt idx="1">
-                  <c:v>52</c:v>
+                  <c:v>64.3</c:v>
                 </c:pt>
                 <c:pt idx="2">
-                  <c:v>72</c:v>
+                  <c:v>49.4</c:v>
+                </c:pt>
+                <c:pt idx="3">
+                  <c:v>45.9</c:v>
+                </c:pt>
+                <c:pt idx="4">
+                  <c:v>49.8</c:v>
+                </c:pt>
+                <c:pt idx="5">
+                  <c:v>45.6</c:v>
+                </c:pt>
+                <c:pt idx="6">
+                  <c:v>48.2</c:v>
+                </c:pt>
+                <c:pt idx="7">
+                  <c:v>47.8</c:v>
+                </c:pt>
+                <c:pt idx="8">
+                  <c:v>56.8</c:v>
+                </c:pt>
+                <c:pt idx="9">
+                  <c:v>46.2</c:v>
+                </c:pt>
+                <c:pt idx="10">
+                  <c:v>45.2</c:v>
+                </c:pt>
+                <c:pt idx="11">
+                  <c:v>61.5</c:v>
+                </c:pt>
+                <c:pt idx="12">
+                  <c:v>49.1</c:v>
+                </c:pt>
+                <c:pt idx="13">
+                  <c:v>50.5</c:v>
+                </c:pt>
+                <c:pt idx="14">
+                  <c:v>55.6</c:v>
                 </c:pt>
               </c:numCache>
             </c:numRef>
           </c:xVal>
           <c:yVal>
             <c:numRef>
-              <c:f>Sheet1!$B$2:$B$4</c:f>
+              <c:f>Sheet1!$B$2:$B$16</c:f>
               <c:numCache>
                 <c:formatCode>General</c:formatCode>
-                <c:ptCount val="3"/>
+                <c:ptCount val="15"/>
                 <c:pt idx="0">
-                  <c:v>99.4</c:v>
+                  <c:v/>
                 </c:pt>
                 <c:pt idx="1">
                   <c:v/>
                 </c:pt>
                 <c:pt idx="2">
                   <c:v/>
+                </c:pt>
+                <c:pt idx="3">
+                  <c:v/>
+                </c:pt>
+                <c:pt idx="4">
+                  <c:v/>
+                </c:pt>
+                <c:pt idx="5">
+                  <c:v/>
+                </c:pt>
+                <c:pt idx="6">
+                  <c:v/>
+                </c:pt>
+                <c:pt idx="7">
+                  <c:v/>
+                </c:pt>
+                <c:pt idx="8">
+                  <c:v/>
+                </c:pt>
+                <c:pt idx="9">
+                  <c:v/>
+                </c:pt>
+                <c:pt idx="10">
+                  <c:v/>
+                </c:pt>
+                <c:pt idx="11">
+                  <c:v>100</c:v>
+                </c:pt>
+                <c:pt idx="12">
+                  <c:v>100</c:v>
+                </c:pt>
+                <c:pt idx="13">
+                  <c:v>100</c:v>
+                </c:pt>
+                <c:pt idx="14">
+                  <c:v>99.3</c:v>
                 </c:pt>
               </c:numCache>
             </c:numRef>
@@ -1106,7 +1611,7 @@
               <c:strCache>
                 <c:ptCount val="1"/>
                 <c:pt idx="0">
-                  <c:v>Core (AGENT_04–11)</c:v>
+                  <c:v>Core (1-6mo)</c:v>
                 </c:pt>
               </c:strCache>
             </c:strRef>
@@ -1122,7 +1627,7 @@
           </c:spPr>
           <c:marker>
             <c:symbol val="circle"/>
-            <c:size val="16"/>
+            <c:size val="12"/>
             <c:spPr>
               <a:solidFill>
                 <a:srgbClr val="492C73"/>
@@ -1139,35 +1644,107 @@
           </c:marker>
           <c:xVal>
             <c:numRef>
-              <c:f>Sheet1!$A$2:$A$4</c:f>
+              <c:f>Sheet1!$A$2:$A$16</c:f>
               <c:numCache>
                 <c:formatCode>General</c:formatCode>
-                <c:ptCount val="3"/>
+                <c:ptCount val="15"/>
                 <c:pt idx="0">
-                  <c:v>38</c:v>
+                  <c:v>76.5</c:v>
                 </c:pt>
                 <c:pt idx="1">
-                  <c:v>52</c:v>
+                  <c:v>64.3</c:v>
                 </c:pt>
                 <c:pt idx="2">
-                  <c:v>72</c:v>
+                  <c:v>49.4</c:v>
+                </c:pt>
+                <c:pt idx="3">
+                  <c:v>45.9</c:v>
+                </c:pt>
+                <c:pt idx="4">
+                  <c:v>49.8</c:v>
+                </c:pt>
+                <c:pt idx="5">
+                  <c:v>45.6</c:v>
+                </c:pt>
+                <c:pt idx="6">
+                  <c:v>48.2</c:v>
+                </c:pt>
+                <c:pt idx="7">
+                  <c:v>47.8</c:v>
+                </c:pt>
+                <c:pt idx="8">
+                  <c:v>56.8</c:v>
+                </c:pt>
+                <c:pt idx="9">
+                  <c:v>46.2</c:v>
+                </c:pt>
+                <c:pt idx="10">
+                  <c:v>45.2</c:v>
+                </c:pt>
+                <c:pt idx="11">
+                  <c:v>61.5</c:v>
+                </c:pt>
+                <c:pt idx="12">
+                  <c:v>49.1</c:v>
+                </c:pt>
+                <c:pt idx="13">
+                  <c:v>50.5</c:v>
+                </c:pt>
+                <c:pt idx="14">
+                  <c:v>55.6</c:v>
                 </c:pt>
               </c:numCache>
             </c:numRef>
           </c:xVal>
           <c:yVal>
             <c:numRef>
-              <c:f>Sheet1!$C$2:$C$4</c:f>
+              <c:f>Sheet1!$C$2:$C$16</c:f>
               <c:numCache>
                 <c:formatCode>General</c:formatCode>
-                <c:ptCount val="3"/>
+                <c:ptCount val="15"/>
                 <c:pt idx="0">
                   <c:v/>
                 </c:pt>
                 <c:pt idx="1">
-                  <c:v>98.7</c:v>
+                  <c:v/>
                 </c:pt>
                 <c:pt idx="2">
+                  <c:v/>
+                </c:pt>
+                <c:pt idx="3">
+                  <c:v>99.2</c:v>
+                </c:pt>
+                <c:pt idx="4">
+                  <c:v>100</c:v>
+                </c:pt>
+                <c:pt idx="5">
+                  <c:v>100</c:v>
+                </c:pt>
+                <c:pt idx="6">
+                  <c:v>100</c:v>
+                </c:pt>
+                <c:pt idx="7">
+                  <c:v>100</c:v>
+                </c:pt>
+                <c:pt idx="8">
+                  <c:v>92.9</c:v>
+                </c:pt>
+                <c:pt idx="9">
+                  <c:v>100</c:v>
+                </c:pt>
+                <c:pt idx="10">
+                  <c:v>100</c:v>
+                </c:pt>
+                <c:pt idx="11">
+                  <c:v/>
+                </c:pt>
+                <c:pt idx="12">
+                  <c:v/>
+                </c:pt>
+                <c:pt idx="13">
+                  <c:v/>
+                </c:pt>
+                <c:pt idx="14">
                   <c:v/>
                 </c:pt>
               </c:numCache>
@@ -1184,7 +1761,7 @@
               <c:strCache>
                 <c:ptCount val="1"/>
                 <c:pt idx="0">
-                  <c:v>New Hire (AGENT_01–03)</c:v>
+                  <c:v>New Hire (&lt;30d)</c:v>
                 </c:pt>
               </c:strCache>
             </c:strRef>
@@ -1200,7 +1777,7 @@
           </c:spPr>
           <c:marker>
             <c:symbol val="circle"/>
-            <c:size val="16"/>
+            <c:size val="12"/>
             <c:spPr>
               <a:solidFill>
                 <a:srgbClr val="E39A1C"/>
@@ -1217,36 +1794,108 @@
           </c:marker>
           <c:xVal>
             <c:numRef>
-              <c:f>Sheet1!$A$2:$A$4</c:f>
+              <c:f>Sheet1!$A$2:$A$16</c:f>
               <c:numCache>
                 <c:formatCode>General</c:formatCode>
-                <c:ptCount val="3"/>
+                <c:ptCount val="15"/>
                 <c:pt idx="0">
-                  <c:v>38</c:v>
+                  <c:v>76.5</c:v>
                 </c:pt>
                 <c:pt idx="1">
-                  <c:v>52</c:v>
+                  <c:v>64.3</c:v>
                 </c:pt>
                 <c:pt idx="2">
-                  <c:v>72</c:v>
+                  <c:v>49.4</c:v>
+                </c:pt>
+                <c:pt idx="3">
+                  <c:v>45.9</c:v>
+                </c:pt>
+                <c:pt idx="4">
+                  <c:v>49.8</c:v>
+                </c:pt>
+                <c:pt idx="5">
+                  <c:v>45.6</c:v>
+                </c:pt>
+                <c:pt idx="6">
+                  <c:v>48.2</c:v>
+                </c:pt>
+                <c:pt idx="7">
+                  <c:v>47.8</c:v>
+                </c:pt>
+                <c:pt idx="8">
+                  <c:v>56.8</c:v>
+                </c:pt>
+                <c:pt idx="9">
+                  <c:v>46.2</c:v>
+                </c:pt>
+                <c:pt idx="10">
+                  <c:v>45.2</c:v>
+                </c:pt>
+                <c:pt idx="11">
+                  <c:v>61.5</c:v>
+                </c:pt>
+                <c:pt idx="12">
+                  <c:v>49.1</c:v>
+                </c:pt>
+                <c:pt idx="13">
+                  <c:v>50.5</c:v>
+                </c:pt>
+                <c:pt idx="14">
+                  <c:v>55.6</c:v>
                 </c:pt>
               </c:numCache>
             </c:numRef>
           </c:xVal>
           <c:yVal>
             <c:numRef>
-              <c:f>Sheet1!$D$2:$D$4</c:f>
+              <c:f>Sheet1!$D$2:$D$16</c:f>
               <c:numCache>
                 <c:formatCode>General</c:formatCode>
-                <c:ptCount val="3"/>
+                <c:ptCount val="15"/>
                 <c:pt idx="0">
+                  <c:v>94.7</c:v>
+                </c:pt>
+                <c:pt idx="1">
+                  <c:v>96</c:v>
+                </c:pt>
+                <c:pt idx="2">
+                  <c:v>91.7</c:v>
+                </c:pt>
+                <c:pt idx="3">
                   <c:v/>
                 </c:pt>
-                <c:pt idx="1">
+                <c:pt idx="4">
                   <c:v/>
                 </c:pt>
-                <c:pt idx="2">
-                  <c:v>93.8</c:v>
+                <c:pt idx="5">
+                  <c:v/>
+                </c:pt>
+                <c:pt idx="6">
+                  <c:v/>
+                </c:pt>
+                <c:pt idx="7">
+                  <c:v/>
+                </c:pt>
+                <c:pt idx="8">
+                  <c:v/>
+                </c:pt>
+                <c:pt idx="9">
+                  <c:v/>
+                </c:pt>
+                <c:pt idx="10">
+                  <c:v/>
+                </c:pt>
+                <c:pt idx="11">
+                  <c:v/>
+                </c:pt>
+                <c:pt idx="12">
+                  <c:v/>
+                </c:pt>
+                <c:pt idx="13">
+                  <c:v/>
+                </c:pt>
+                <c:pt idx="14">
+                  <c:v/>
                 </c:pt>
               </c:numCache>
             </c:numRef>
@@ -1284,7 +1933,7 @@
         <c:scaling>
           <c:orientation val="minMax"/>
           <c:max val="80"/>
-          <c:min val="30"/>
+          <c:min val="40"/>
         </c:scaling>
         <c:delete val="0"/>
         <c:axPos val="b"/>
@@ -1357,7 +2006,7 @@
         <c:scaling>
           <c:orientation val="minMax"/>
           <c:max val="100"/>
-          <c:min val="92"/>
+          <c:min val="90"/>
         </c:scaling>
         <c:delete val="0"/>
         <c:axPos val="l"/>
@@ -1393,7 +2042,7 @@
                     </a:solidFill>
                     <a:latin typeface="+mn-lt"/>
                   </a:rPr>
-                  <a:t>QA score %</a:t>
+                  <a:t>Audited QA score %</a:t>
                 </a:r>
               </a:p>
             </c:rich>
@@ -1855,25 +2504,26 @@
             <a:r>
               <a:rPr lang="en-US" dirty="0"/>
               <a:t>TIMING: 0:00 – 1:30 (90s)  ·  PACE: Confident, direct
+DATA SOURCE: dashboard-ready.csv (2,800 reviews, Sep 6 – Oct 5, 2026)
 CORE TALKING POINTS
-1. The headline: content accuracy is exceptional (98.6% QA pass rate), but overall SLA compliance has slipped to 78.2%, below the 95.0% service agreement.
-2. The discovery: the deficit is not systemic. Routine queues (Spam_Commercial and Fraud_Scams) operate at 96.6% SLA attainment.
-3. The concentration: 100% of the SLA drag sits in (a) high-complexity video queues (Violence_HighRisk, Emergency_TCO) averaging ~109s AHT and (b) an isolated 4-day viral event (Days 18–21) that overwhelmed manual review capacity.
-4. The takeaway: no additional headcount budget is needed. Rebalancing queue allocation and tuning triage thresholds restores SLA above 96.0% within 14 operational days.
+1. The headline: decision quality is strong (98.6% average audited QA score; 333 of 340 audits error-free), but SLA attainment is 78.2% against a 95.0% contractual target.
+2. The discovery: the deficit is not systemic. Commercial Spam and Fraud &amp; Scams together run at 96.7% SLA.
+3. The concentration: 565 of 610 SLA breaches (93%) sit in Violence_HighRisk, Hate_Speech and Emergency_TCO. A further 209 breaches (34% of all breaches) landed in just 4 days, Sep 24–27, when the intake mix shifted toward high-risk content and SLA fell to 41.1%.
+4. The takeaway: volume did not grow, so this is a routing and capacity-allocation problem, not a headcount problem. The target is ≥95% SLA within 14 operational days with no new hires.
 SPOKEN SCRIPT
-Good morning, leadership team. My name is Wesley Taguinod, and today I am presenting the operational performance briefing and SLA recovery strategy for our Content Moderation &amp; Trust and Safety operations.
+Good morning, leadership team. My name is Wesley Taguinod, and today I am presenting the operational performance briefing and SLA recovery strategy for our Content Moderation and Trust &amp; Safety operations.
 [Pause 1s — glance at audience]
-Across 2,800 operational reviews evaluated over the past 30 days, our account operates at:
-• A 98.6% Audited QA Accuracy Rate,
-• A weighted Average Handling Time of 52.5 seconds, and
-• An overall SLA Attainment Rate of 78.2% — trailing our contractual 95.0% commitment.
+Across 2,800 reviews over the past 30 days, our account operates at:
+• A 98.6% average audited QA score,
+• A weighted average handling time of 52.5 seconds, and
+• An overall SLA attainment of 78.2% — trailing our contractual 95.0% commitment.
 [Gesture toward right KPI cards]
-Here is the bottom line up front: our operational challenge is not a quality failure, and it is not widespread. Our frontline moderators are making sound, defensible decisions — our False Negative rate, which represents harmful content mistakenly left live, is just 0.59%.
-Furthermore, our high-volume operational workflows — Commercial Spam and Fraud — are running smoothly above SLA targets at 96.6% compliance.
-The SLA breach is strictly isolated to two specific operational bottlenecks:
-1. Extreme media complexity in our Violence and Emergency TCO queues, where video handling times average 109 seconds per item, and
-2. An acute, 4-day viral surge between September 24 and 27 that temporarily created an unstaffed queue backlog.
-Because this issue is localized, we do not need to hire additional full-time agents. By reallocating existing bandwidth from our automated spam queues and applying Erlang-C capacity leveling, we can bring the entire account back into full SLA compliance above 96.0%. Let me show you what the operational data reveals.
+Here is the bottom line up front: our challenge is not a quality failure, and it is not widespread. Of 340 audited decisions, 333 were error-free. Our false negative rate — harmful content mistakenly left live — is just 0.59%.
+Our high-volume deterministic queues, Commercial Spam and Fraud, are running above target at 96.7% SLA.
+The breach is concentrated in two places:
+1. Our contextual and high-risk queues — Violence, Hate Speech and Emergency TCO — hold 93% of all SLA breaches.
+2. A 4-day window, September 24 to 27, when the intake mix shifted sharply toward high-risk video and SLA fell to 41%.
+Daily volume did not rise during that window. That tells us this is an allocation problem, not a headcount problem. By shifting existing capacity toward the high-risk queues when the mix changes, tightening how we route video, and calibrating our newest agents, we are targeting 95% SLA or better within 14 operational days. Let me show you what the data reveals.
 [Transition: advance to Slide 2]</a:t>
             </a:r>
             <a:endParaRPr lang="en-US" dirty="0"/>
@@ -1963,20 +2613,21 @@
             <a:r>
               <a:rPr lang="en-US" dirty="0"/>
               <a:t>TIMING: 1:30 – 3:30 (120s)  ·  PACE: Methodical, grounded
+DATA SOURCE: dashboard-ready.csv (2,800 reviews, Sep 6 – Oct 5, 2026)
 CORE TALKING POINTS
-1. Mathematical rigor: all AHT figures are duration-weighted across total seconds; SLA compliance is calculated at the transaction level, not by averaging queue percentages.
-2. The queue divide: deterministic queues (Spam &amp; Fraud) = 1,346 reviews (48.1% of volume) at 12–36s AHT and 96.6% SLA; contextual &amp; egregious queues (Violence, Hate Speech, TCO) = 1,454 reviews at 44–110s AHT and 57%–65% SLA.
-3. HITL efficiency: automated ML filters deflect nearly half of incoming volume (47.8%), letting human reviewers focus on contextual judgment.
+1. Mathematical rigor: AHT is duration-weighted across total handling seconds, and SLA is calculated at the transaction level (610 breached of 2,800), not by averaging queue percentages.
+2. The queue divide: Spam &amp; Fraud = 1,346 reviews (48.1% of volume) at 12–36s AHT and 96.7% SLA. Violence, Hate Speech &amp; TCO = 1,454 reviews at 44–110s AHT and 61.1% SLA, holding 565 of 610 breaches (93%).
+3. HITL efficiency: automation resolves 47.8% of volume (22.8% auto-approved, 25.0% auto-rejected). But it is uneven: Spam is 75% automated, Violence 33% and Emergency TCO only 24%.
 SPOKEN SCRIPT
-To understand where our performance variance originates, we decomposed our 2,800 reviews across our 5 operational queues and 4 content modalities.
+To understand where the variance comes from, we broke our 2,800 reviews down across 5 queues and 4 content modalities.
 [Point to left chart: Queue SLA Attainment]
-The queue-level data reveals a dramatic split:
-• On one side, Commercial Spam and Fraud &amp; Scams are model operations. Handling nearly half of our entire account volume — 1,346 interactions — they maintain 96.4% and 96.9% SLA compliance, with handling times under 37 seconds.
-• On the other side, our contextual and high-risk queues drag the entire account down: Hate Speech operates at 65.4% SLA, while Violence and Emergency TCO run at 57.6% and 56.7%.
+The queue-level data shows a sharp split:
+• Commercial Spam and Fraud &amp; Scams are model operations. They handle nearly half our volume — 1,346 reviews — at 96.4% and 96.9% SLA, with handling times under 37 seconds.
+• Our contextual and high-risk queues pull the account down: Hate Speech at 65.4%, Violence at 57.6% and Emergency TCO at 56.7%. Together these three queues hold 93% of every SLA breach we recorded.
 [Point to right visual: HITL Funnel]
-Now look at how content flows into agent hands. Our Human-in-the-Loop automation engine handles nearly 48% of volume without human touch — 25% auto-approved and 22% auto-rejected based on hash matching and high-confidence AI classifiers.
-This leaves roughly 47% for manual frontline review and 5% for Tier-2 senior escalations.
-This distribution tells us our AI triage is functioning, but the manual queues are bearing an uneven burden of complex media. To solve this, we must look at media modality and temporal arrival patterns.
+Now look at how work reaches agents. Our Human-in-the-Loop automation resolves 47.8% of volume without a human touch — about 23% auto-approved and 25% auto-rejected by hash matching and high-confidence classifiers.
+That leaves 44% for frontline manual review and 8% for Tier-2 escalation.
+The catch is that automation is uneven: three-quarters of Spam is automated, but only a third of Violence and a quarter of Emergency TCO. The human queues carry the hardest content. To see why they breach, we need to look at media type and what happened over time.
 [Transition: advance to Slide 3]</a:t>
             </a:r>
             <a:endParaRPr lang="en-US" dirty="0"/>
@@ -2066,27 +2717,23 @@
             <a:r>
               <a:rPr lang="en-US" dirty="0"/>
               <a:t>TIMING: 3:30 – 6:00 (150s)  ·  PACE: Analytical core
+DATA SOURCE: dashboard-ready.csv (2,800 reviews, Sep 6 – Oct 5, 2026)
 CORE TALKING POINTS
-1. The media multiplier: AHT is driven by media modality, not agent inefficiency. A short video takes 5× longer to evaluate than a text post.
-2. The surge shock: the account was staffed for ~80 items/day. During the Days 18–21 viral spike, arrivals surged 135%, creating an immediate queuing delay.
-3. Workforce protection constraint: egregious material restricts agents to 5.5-hour exposure shifts. Forcing 10-hour shifts would violate duty-of-care policy.
+1. The media multiplier: AHT is driven by media type, not agent effort. Text averages 15.8s, static images 31.9s, short video 107.7s (6.8× text) and live streams 189.6s (12× text). Video and live are 28% of volume but 69% of handling hours.
+2. The surge window (Sep 24–27): daily volume did not rise (95/day before vs. 89/day during). The mix shifted: Violence + Emergency TCO rose from 24% to 43% of intake, weighted AHT rose 31% (49.7s → 65.3s), average turnaround nearly doubled (134 → 241 min) and SLA fell to 41.1%. Those 4 days produced 209 of 610 breaches.
+3. Workforce protection constraint: all 719 egregious items sit in Violence (418), TCO (164) and Hate Speech (137). Exposure caps (5.5-hour shifts) mean the gap cannot be closed by lengthening shifts.
 SPOKEN SCRIPT
-This brings us to the core diagnostic question: why did SLA compliance fall to 78%, and what specifically caused the backlog?
-Our deep dive identified two undeniable root causes.
-[Focus on left card: Media Modality Complexity]
-First, look at the media modality breakdown on the left.
-• Reviewing a standard text post takes an agent just 28.4 seconds.
-• Evaluating a static image takes 54 seconds.
-• However, short-form video jumps to 148 seconds, and live streams average over 4 minutes per review.
-Here is the critical operational insight: video and live streams account for only 28% of incoming volume, but they consume 64% of all productive agent review hours. When a queue shifts toward video content, standard capacity models break.
-[Focus on right card: The Viral Surge]
-Second, on the right, we examine our 30-day temporal trend.
-For the first 17 days of the month, our account performed flawlessly: averaging 80 reviews a day with a 97.4% SLA attainment.
-Then, between September 24 and 27 — Days 18 through 21 — a viral incident occurred. Daily volume spiked by 135%, peaking at nearly 200 items per day.
-[Point out the SLA dip in Days 18–21]
-Because our 15 frontline agents were sized for steady-state volume, queue wait times exploded. In our Emergency TCO queue — which carries a strict 1-hour legal removal SLA under European regulations — TAT exceeded 70 minutes, driving our SLA attainment down to 48% during that 4-day window.
-Furthermore, because 719 of these reviews involved egregious content, operational safety rules properly restricted agent shifts to 5.5 hours with mandatory wellness intervals.
-The conclusion is clear: our agents did not work slower. The queue experienced a structural mismatch between video-heavy arrival curves and fixed shift schedules.
+This brings us to the core diagnostic question: why did SLA fall to 78%, and where did the backlog come from?
+The data points to two root causes.
+[Focus on left card: Media Modality]
+First, media type. Reviewing a text post takes an agent about 16 seconds. A static image takes 32 seconds. Short-form video jumps to 108 seconds, and live streams average over three minutes.
+Here is the critical insight: video and live streams are only 28% of our volume, but they consume 69% of all handling hours. Any day the intake tilts toward video, our capacity is stretched.
+[Focus on right card: Daily SLA]
+Second, look at the daily trend on the right. Most days ran between 75 and 94%. Then, from September 24 to 27, SLA collapsed to roughly 40% a day.
+[Point to the shaded window and the three facts below]
+Importantly, volume did not spike — we averaged 89 items a day during the window versus 95 before it. What changed was the mix: Violence and Emergency TCO rose from 24% to 43% of our intake. Handling time per item rose 31%, and average turnaround nearly doubled, from 134 to 241 minutes. Emergency TCO, which carries a strict 1-hour legal removal SLA, averaged 78 minutes to decision and met its SLA only 29% of the time in those 4 days.
+Furthermore, every one of our 719 egregious items sits in these high-risk queues, and our duty-of-care rules properly cap that exposure at 5.5-hour shifts with wellness rotations.
+The conclusion: our agents did not slow down. We had a structural mismatch between a video-heavy, high-risk intake mix and a fixed allocation of capacity.
 [Transition: advance to Slide 4]</a:t>
             </a:r>
             <a:endParaRPr lang="en-US" dirty="0"/>
@@ -2176,26 +2823,25 @@
             <a:r>
               <a:rPr lang="en-US" dirty="0"/>
               <a:t>TIMING: 6:00 – 8:00 (120s)  ·  PACE: Objective, diagnostic
+DATA SOURCE: dashboard-ready.csv (2,800 reviews, Sep 6 – Oct 5, 2026)
 CORE TALKING POINTS
-1. Tenure matures rapidly: senior agents are 47% faster and make 75% fewer audit errors than new hires; coaching and familiarity drive efficiency.
-2. Error taxonomy isolation: total audit errors were low; false negatives occurred almost exclusively when new hires evaluated nuanced hate speech or disguised slurs.
-3. Mathematical proof of the gap: BA guide capacity formulas show 15 FTEs were sufficient at steady state, but peak video volume required 22 FTEs.
+1. Tenure and speed: on manual reviews, where speed matters, seniors average 84.2s vs. 96.8s for core and 125.2s for new hires (33% faster than new hires). Seniors' overall AHT (54.0s) is higher than core (48.0s) only because they carry more egregious work (30% of their items vs. 23%). On short video, core agents are fastest (102s) and new hires slowest (123s, 20% slower); on live streams new hires are 41% slower than core.
+2. Error taxonomy: 7 errors in 340 audits (4 false positives, 2 false negatives, 1 wrong policy). New hires made 4 of the 7 (6.8% error rate vs. 1.1% for tenured agents), and 3 of those 4 were false positives on static images — over-enforcement, not missed harm.
+3. Capacity math (BA guide Section 5): productive hours = shift × (1 − shrinkage) × occupancy = 4.80h on a standard shift, 3.08h on an egregious 5.5h shift. Applying this to each phase's handling hours, split by egregious vs. standard work: if 15 FTEs covered the pre-surge mix, the Sep 24–27 mix needed 18.9 → 19 FTEs at the same daily volume, a 4-FTE gap. Workload above available servers means Erlang-C queue delay is effectively certain, which matches turnaround nearly doubling.
 SPOKEN SCRIPT
-To turn this diagnostic into an actionable staffing model, we cross-analyzed agent performance and applied our Erlang-C capacity equations.
+To turn this diagnosis into a staffing model, we looked at agent performance and applied the capacity formulas from our operations guide.
 [Point to left scatter: Speed vs Quality]
-On the left, we map our 15 agents across handling speed and audited accuracy.
-Notice the clear clustering by tenure group:
-• Our senior agents in green — Agents 12 through 15 — represent elite performance: achieving 99.4% QA accuracy while maintaining an agile 38-second handle time.
-• Our core agents in purple deliver steady, compliant execution at 98.7% accuracy.
-• Our three new hires in amber — Agents 01, 02, and 03 — average 72 seconds AHT and 93.8% accuracy.
-When we audited their specific errors, they were not careless mistakes; they were False Negatives in hate speech where subtle regional slang escaped detection.
-[Focus on right box: Erlang-C Gap]
-Now look at the workforce math on the right.
-Using Section 5 of our operational guide, we calculate that on standard 8-hour shifts with 25% shrinkage and 80% occupancy, each agent delivers 4.8 productive hours daily.
-However, for agents rotating into our high-risk violence queues, mandatory wellness safeguards reduce shift length to 5.5 hours and raise shrinkage to 30%, yielding only 3.08 productive hours.
-During our steady-state period, our 15 FTEs provided 72 productive hours daily against a 60-hour workload — a healthy 12-hour surplus.
-But when the viral spike hit, workload surged to 102 hours. As our Erlang-C simulator demonstrates, required staffing jumped to 22 FTEs, leaving a 7-agent deficit that pushed queue delay probability above 34%.
-This is the exact mathematical reason our SLA dipped. The good news is, now that we have quantified the shortfall, the solution does not require hiring 7 new people.
+On the left, each dot is one of our 15 agents, plotted by handling time and audited QA score.
+The tenure pattern is clear:
+• Our senior agents in green — Agents 12 through 15 — average 99.8% QA. Their overall handle time looks higher than core because they take on more of the egregious work, but on manual reviews they are our fastest, at 84 seconds.
+• Our core agents in purple deliver 99.2% QA at 48 seconds, and they are our fastest on short video.
+• Our three new hires in amber — Agents 01, 02 and 03 — average 94.5% QA and take 125 seconds on manual reviews.
+When we look at the errors themselves, new hires account for 4 of the 7 audit errors we found, and 3 of those were false positives — over-enforcement on images, not missed harm.
+[Focus on right card: Capacity Gap]
+Now the workforce math on the right.
+On a standard 8-hour shift, with 25% shrinkage and 80% occupancy, each agent delivers 4.8 productive hours. On egregious queues, the 5.5-hour cap and 30% shrinkage leave just 3.08 productive hours.
+During the September 24 to 27 window, the mix shift raised handling time per item from 50 to 65 seconds, and pushed the egregious share of our workload from 47% to 53%. If our 15 agents were sized for the normal mix, that window needed 19 — a 4-agent shortfall, at the same daily volume.
+That is the mechanical reason our SLA dipped. The good news: the gap is 4 FTEs for a few days, which is a routing problem we can solve without hiring.
 [Transition: advance to Slide 5]</a:t>
             </a:r>
             <a:endParaRPr lang="en-US" dirty="0"/>
@@ -2285,31 +2931,33 @@
             <a:r>
               <a:rPr lang="en-US" dirty="0"/>
               <a:t>TIMING: 8:00 – 10:00 (120s)  ·  PACE: Decisive, ROI-focused
+DATA SOURCE: dashboard-ready.csv (2,800 reviews, Sep 6 – Oct 5, 2026)
 CORE TALKING POINTS
-1. Zero budget required: solutions optimize existing agent capacity, queue routing and minor AI threshold calibration.
-2. Measurable accountability: each of the 3 actions has an owner, a milestone timeline and a measurable KPI target.
-3. Sustainable workforce health: wellness safeguards and exposure caps are preserved, so speed gains do not induce burnout or attrition.
+1. Zero budget required: every action reallocates existing capacity, changes routing or adds coaching time; no hires and no new software.
+2. Evidence for each action: (1) the surge mix needed 4 more FTEs while Spam &amp; Fraud use only 22% of handling hours for 48% of volume; (2) new hires are 20% slower than core on short video and 41% slower on live, and Violence/TCO automation (33%/24%) trails Spam (75%); (3) new hires made 4 of 7 audit errors, 3 of them false positives.
+3. Targets, not forecasts: ≥95% account SLA and ≥95% TCO 1-hour SLA are the contractual targets to hit within 14 days. Track them weekly in the dashboard. Excluding the Sep 24–27 window, SLA was already 83.6%, so most of the gap is the mix-shift response.
+4. Sustainable workforce health: exposure caps and rotations stay in place, so speed gains do not come at the cost of burnout or attrition.
 SPOKEN SCRIPT
-That brings us to our decisive operational plan: how do we permanently fix this without increasing payroll?
-We propose three targeted, data-backed operational interventions ready for execution tomorrow morning.
+That brings us to the plan: how do we fix this permanently without adding payroll?
+We propose three targeted, data-backed interventions.
 [Point to Action 1]
-Action 1: Dynamic Cross-Queue Reallocation &amp; Erlang-C Leveling.
-• Because Commercial Spam and Fraud currently operate with excess capacity at 96.6% SLA, we will cross-train and dynamically reallocate 3 FTEs into high-risk queues during peak diurnal arrival hours (11:00 AM to 8:00 PM).
-• By automating de-duplication on bulk commercial spam, we immediately recapture 15 productive agent hours per week.
+Action 1: mix-triggered cross-queue flex staffing.
+• Our model shows the high-risk mix needed 4 more FTEs. So when Violence and Emergency TCO exceed 35% of daily intake, we flex 4 agents' worth of capacity out of Spam and Fraud into the high-risk queues.
+• Spam and Fraud can absorb this: they use only 22% of our handling hours for nearly half our volume, and three-quarters of Spam is already automated.
 [Point to Action 2]
-Action 2: AI Triage Calibration &amp; Senior Video Routing.
-• We will adjust our automated triage confidence score for verified commercial accounts from 92% down to 88%, expanding auto-resolution from 47.8% to 54.0%.
-• Simultaneously, we will route short-form video exclusively to our senior agent cohort, utilizing their 38-second navigation speed to compress video AHT from 148 seconds down to 115 seconds.
+Action 2: smarter video routing and a triage pilot.
+• Video and live streams drive 69% of our handling hours. Our new hires are 20% slower than core agents on short video and 41% slower on live streams, so we route that content to core and senior agents.
+• We will also pilot wider automated triage in Violence and Emergency TCO, which are only 33% and 24% automated today versus 75% in Spam — with QA sign-off before any threshold change.
 [Point to Action 3]
-Action 3: Targeted Calibration &amp; Automated Wellness Rotation.
-• We will institute daily 20-minute calibration huddles between Senior Agents and our 3 new hires, closing the subtle slang gap and eliminating False Negatives in hate speech.
-• We will automate shift scheduling so that no agent exceeds 2 consecutive hours in egregious queues, rotating them into lightweight spam review to protect workforce mental health.
-[Highlight bottom banner: Executive Takeaway]
-Here is the final executive takeaway:
-• This plan requires zero new hires and zero external software expenditures.
-• Within 14 operational days, our capacity model projects account-wide SLA attainment will rebound from 78.2% to 96.5%, while keeping our audited accuracy firmly above 98.5%.
-• Most importantly, our European 1-hour emergency legal SLA will achieve 98.0% compliance, safeguarding platform integrity and avoiding regulatory fines.
-Thank you for your time and leadership. I will now open the floor to questions.</a:t>
+Action 3: new-hire calibration and automated wellness rotation.
+• Daily 20-minute calibration huddles pair our 3 new hires with senior mentors, who run at 99.8% QA. The focus is over-enforcement: 3 of the new hires' 4 audit errors were false positives.
+• We automate scheduling so no agent spends more than 2 consecutive hours in egregious queues, within the 5.5-hour cap.
+[Highlight bottom banner: Recovery Targets]
+The executive takeaway:
+• This plan needs zero new hires and zero external software spend.
+• Our target is to bring account SLA from 78.2% to 95% or better within 14 operational days. Outside the 4-day surge window we were already at 83.6%, so most of the gap is in how we respond to mix shifts.
+• Most importantly, we target 95% or better on the Emergency TCO 1-hour legal SLA — up from 56.7% today — protecting platform integrity and our regulatory position.
+Thank you for your time. I will now open the floor to questions.</a:t>
             </a:r>
             <a:endParaRPr lang="en-US" dirty="0"/>
           </a:p>
@@ -2398,12 +3046,12 @@
             <a:r>
               <a:rPr lang="en-US" dirty="0"/>
               <a:t>BACKUP SLIDE — use during the 2:00 synthesis &amp; leadership Q&amp;A.
-Q1: "If we reallocate 3 agents from Spam to High-Risk Video, won't our Spam queue SLA collapse?"
-"No. Commercial Spam currently operates at 12.3 seconds AHT with a 96.4% SLA and an automated triage rate of 75%. Because spam items are largely deterministic and auto-rejected by hash algorithms, our capacity model indicates Spam can maintain a 94.5% SLA with 3 fewer FTEs, while those same 3 agents provide 45 hours of critical relief to our breached video queues."
+Q1: "If we flex capacity from Spam and Fraud into the high-risk queues, won't the Spam SLA collapse?"
+"Unlikely. Commercial Spam runs at 12.3 seconds AHT and 96.4% SLA, and 75% of Spam items are resolved automatically. Spam and Fraud together account for 48% of our volume but only 22% of our handling hours. And the flex only triggers on days when Violence and TCO exceed 35% of intake. During the Sep 24–27 window Spam and Fraud also dipped (61% and 68%) because the whole floor was saturated, so relieving the high-risk queues helps every queue."
 Q2: "Why not simply mandate 8-hour shifts for all agents to clear the backlog?"
-"Mandating 8-hour shifts in high-risk violence queues directly breaches industry duty-of-care guidelines and leads to rapid cognitive fatigue. In our data, when agents spend more than 2 consecutive hours in egregious queues, False Negatives increase by 40%. The 5.5-hour shift cap paired with rotation to non-egregious workflows maintains our 98.6% accuracy without driving agent attrition."
-Q3: "How does lowering the AI triage threshold from 92% to 88% affect False Positives?"
-"We tested this in our historical audit logs: lowering the threshold to 88% on Commercial Spam only increases the False Positive risk by 0.08%, well within our acceptable risk tolerance of 2.0%. More importantly, any disputed removal in spam is resolved via our post-moderation appeals workflow, which already operates at a low 15.8% overturn rate."</a:t>
+"Because the backlog sits exactly where the exposure is. All 719 egregious items are in Violence, Hate Speech and Emergency TCO, and our duty-of-care policy caps that exposure at 5.5-hour shifts. We already saw a warning sign: audited QA in the Violence queue dipped to 88.9% during the surge window, versus 100% before it (a small sample of 9 audits, but the direction matters). Rotation into non-egregious work protects accuracy without driving attrition."
+Q3: "Does widening automated triage increase false positives?"
+"That is why it is a pilot with QA sign-off, not a blanket change. Today, automated decisions audit well: auto-approved items scored 100% across 75 audits, and auto-rejected items 97.3% across 81 audits. Disputed decisions also have a safety net: of 190 appeals this period, only 30 (15.8%) were overturned."</a:t>
             </a:r>
             <a:endParaRPr lang="en-US" dirty="0"/>
           </a:p>
@@ -3516,7 +4164,7 @@
                   <a:schemeClr val="tx1"/>
                 </a:solidFill>
               </a:rPr>
-              <a:t>The miss is concentrated in video-heavy Violence &amp; Emergency TCO queues (~109s AHT) and a 4-day viral surge (Sep 24–27).</a:t>
+              <a:t>93% of breaches sit in Violence, Hate Speech &amp; TCO, and a 4-day high-risk mix shift (Sep 24–27) cut SLA to 41%.</a:t>
             </a:r>
             <a:endParaRPr lang="en-US" sz="1600" dirty="0"/>
           </a:p>
@@ -3544,7 +4192,7 @@
                   <a:schemeClr val="tx1"/>
                 </a:solidFill>
               </a:rPr>
-              <a:t>Rebalancing existing capacity restores SLA to </a:t>
+              <a:t>Rebalancing existing capacity targets </a:t>
             </a:r>
             <a:pPr indent="0" marL="0">
               <a:buNone/>
@@ -3555,7 +4203,7 @@
                   <a:schemeClr val="accent1"/>
                 </a:solidFill>
               </a:rPr>
-              <a:t>≥96% within 14 days, with zero new hires.</a:t>
+              <a:t>≥95% SLA within 14 days, with zero new hires.</a:t>
             </a:r>
             <a:endParaRPr lang="en-US" sz="1600" dirty="0"/>
           </a:p>
@@ -3968,7 +4616,7 @@
       </p:sp>
       <p:sp>
         <p:nvSpPr>
-          <p:cNvPr id="23" name="KPI Audited QA accuracy"/>
+          <p:cNvPr id="23" name="KPI Avg. audited QA score"/>
           <p:cNvSpPr/>
           <p:nvPr/>
         </p:nvSpPr>
@@ -4059,7 +4707,7 @@
                   <a:schemeClr val="bg1"/>
                 </a:solidFill>
               </a:rPr>
-              <a:t>Audited QA accuracy</a:t>
+              <a:t>Avg. audited QA score</a:t>
             </a:r>
             <a:endParaRPr lang="en-US" sz="1500" dirty="0"/>
           </a:p>
@@ -4860,7 +5508,7 @@
         <p:spPr>
           <a:xfrm>
             <a:off x="7726680" y="3419856"/>
-            <a:ext cx="1493356" cy="219456"/>
+            <a:ext cx="1440386" cy="219456"/>
           </a:xfrm>
           <a:prstGeom prst="rect">
             <a:avLst/>
@@ -4879,7 +5527,7 @@
         </p:nvSpPr>
         <p:spPr>
           <a:xfrm>
-            <a:off x="9311476" y="3392424"/>
+            <a:off x="9258506" y="3392424"/>
             <a:ext cx="731520" cy="274320"/>
           </a:xfrm>
           <a:prstGeom prst="rect">
@@ -4901,7 +5549,7 @@
                   <a:schemeClr val="tx1"/>
                 </a:solidFill>
               </a:rPr>
-              <a:t>25.2%</a:t>
+              <a:t>22.8%</a:t>
             </a:r>
             <a:endParaRPr lang="en-US" sz="1300" dirty="0"/>
           </a:p>
@@ -4963,7 +5611,7 @@
         <p:spPr>
           <a:xfrm>
             <a:off x="7726680" y="3968496"/>
-            <a:ext cx="1339279" cy="219456"/>
+            <a:ext cx="1579371" cy="219456"/>
           </a:xfrm>
           <a:prstGeom prst="rect">
             <a:avLst/>
@@ -4982,7 +5630,7 @@
         </p:nvSpPr>
         <p:spPr>
           <a:xfrm>
-            <a:off x="9157399" y="3941064"/>
+            <a:off x="9397491" y="3941064"/>
             <a:ext cx="731520" cy="274320"/>
           </a:xfrm>
           <a:prstGeom prst="rect">
@@ -5004,7 +5652,7 @@
                   <a:schemeClr val="tx1"/>
                 </a:solidFill>
               </a:rPr>
-              <a:t>22.6%</a:t>
+              <a:t>25.0%</a:t>
             </a:r>
             <a:endParaRPr lang="en-US" sz="1300" dirty="0"/>
           </a:p>
@@ -5107,7 +5755,7 @@
                   <a:schemeClr val="tx1"/>
                 </a:solidFill>
               </a:rPr>
-              <a:t>46.8%</a:t>
+              <a:t>43.9%</a:t>
             </a:r>
             <a:endParaRPr lang="en-US" sz="1300" dirty="0"/>
           </a:p>
@@ -5169,7 +5817,7 @@
         <p:spPr>
           <a:xfrm>
             <a:off x="7726680" y="5065776"/>
-            <a:ext cx="320005" cy="219456"/>
+            <a:ext cx="524351" cy="219456"/>
           </a:xfrm>
           <a:prstGeom prst="rect">
             <a:avLst/>
@@ -5188,7 +5836,7 @@
         </p:nvSpPr>
         <p:spPr>
           <a:xfrm>
-            <a:off x="8138125" y="5038344"/>
+            <a:off x="8342471" y="5038344"/>
             <a:ext cx="731520" cy="274320"/>
           </a:xfrm>
           <a:prstGeom prst="rect">
@@ -5210,7 +5858,7 @@
                   <a:schemeClr val="tx1"/>
                 </a:solidFill>
               </a:rPr>
-              <a:t>5.4%</a:t>
+              <a:t>8.3%</a:t>
             </a:r>
             <a:endParaRPr lang="en-US" sz="1300" dirty="0"/>
           </a:p>
@@ -5622,7 +6270,7 @@
                   <a:schemeClr val="accent6"/>
                 </a:solidFill>
               </a:rPr>
-              <a:t>64% of agent hours</a:t>
+              <a:t>69% of handling hours</a:t>
             </a:r>
             <a:pPr indent="0" marL="0">
               <a:buNone/>
@@ -5633,7 +6281,7 @@
                   <a:schemeClr val="accent4"/>
                 </a:solidFill>
               </a:rPr>
-              <a:t>  ·  short video 5.2×, live 8.5× text AHT</a:t>
+              <a:t>  ·  short video 6.8×, live 12× text AHT</a:t>
             </a:r>
             <a:endParaRPr lang="en-US" sz="1400" dirty="0"/>
           </a:p>
@@ -5641,7 +6289,7 @@
       </p:sp>
       <p:sp>
         <p:nvSpPr>
-          <p:cNvPr id="11" name="Viral surge card"/>
+          <p:cNvPr id="11" name="Surge window card"/>
           <p:cNvSpPr/>
           <p:nvPr/>
         </p:nvSpPr>
@@ -5670,7 +6318,7 @@
       </p:sp>
       <p:sp>
         <p:nvSpPr>
-          <p:cNvPr id="12" name="Viral surge circle"/>
+          <p:cNvPr id="12" name="Surge window circle"/>
           <p:cNvSpPr/>
           <p:nvPr/>
         </p:nvSpPr>
@@ -5690,7 +6338,7 @@
       </p:sp>
       <p:pic>
         <p:nvPicPr>
-          <p:cNvPr id="13" name="Viral surge icon" descr="Viral surge">    </p:cNvPr>
+          <p:cNvPr id="13" name="Surge window icon" descr="Surge window">    </p:cNvPr>
           <p:cNvPicPr>
             <a:picLocks noChangeAspect="1"/>
           </p:cNvPicPr>
@@ -5742,21 +6390,43 @@
                   <a:schemeClr val="accent1"/>
                 </a:solidFill>
               </a:rPr>
-              <a:t>Surge shock: avg. daily arrivals by phase</a:t>
+              <a:t>Daily SLA attainment vs. 95% target</a:t>
             </a:r>
             <a:endParaRPr lang="en-US" sz="1600" dirty="0"/>
           </a:p>
         </p:txBody>
+      </p:sp>
+      <p:sp>
+        <p:nvSpPr>
+          <p:cNvPr id="15" name="Surge window shading"/>
+          <p:cNvSpPr/>
+          <p:nvPr/>
+        </p:nvSpPr>
+        <p:spPr>
+          <a:xfrm>
+            <a:off x="9533257" y="2418588"/>
+            <a:ext cx="591863" cy="1481328"/>
+          </a:xfrm>
+          <a:prstGeom prst="rect">
+            <a:avLst/>
+          </a:prstGeom>
+          <a:solidFill>
+            <a:schemeClr val="accent6">
+              <a:alpha val="18000"/>
+            </a:schemeClr>
+          </a:solidFill>
+          <a:ln/>
+        </p:spPr>
       </p:sp>
       <p:graphicFrame>
         <p:nvGraphicFramePr>
-          <p:cNvPr id="15" name="Daily arrivals by phase chart" descr="Column chart of average daily arrivals in steady, viral and burn-off phases"/>
+          <p:cNvPr id="16" name="Daily SLA trend chart" descr="Line chart of daily SLA attainment with a dip to about 40% from Sep 24 to 27"/>
           <p:cNvGraphicFramePr/>
           <p:nvPr/>
         </p:nvGraphicFramePr>
         <p:xfrm>
           <a:off x="6415888" y="2212848"/>
-          <a:ext cx="5044288" cy="1965960"/>
+          <a:ext cx="5044288" cy="2057400"/>
         </p:xfrm>
         <a:graphic xmlns:a="http://schemas.openxmlformats.org/drawingml/2006/main">
           <a:graphicData uri="http://schemas.openxmlformats.org/drawingml/2006/chart">
@@ -5766,36 +6436,216 @@
       </p:graphicFrame>
       <p:sp>
         <p:nvSpPr>
-          <p:cNvPr id="16" name="Phase 1 SLA chip"/>
+          <p:cNvPr id="17" name="Text 11"/>
+          <p:cNvSpPr txBox="1"/>
+          <p:nvPr/>
+        </p:nvSpPr>
+        <p:spPr>
+          <a:xfrm>
+            <a:off x="6532376" y="3954780"/>
+            <a:ext cx="822960" cy="228600"/>
+          </a:xfrm>
+          <a:prstGeom prst="rect">
+            <a:avLst/>
+          </a:prstGeom>
+          <a:noFill/>
+          <a:ln/>
+        </p:spPr>
+        <p:txBody>
+          <a:bodyPr wrap="square" lIns="0" tIns="0" rIns="0" bIns="0" rtlCol="0" anchor="t"/>
+          <a:lstStyle/>
+          <a:p>
+            <a:pPr algn="ctr" indent="0" marL="0">
+              <a:buNone/>
+            </a:pPr>
+            <a:r>
+              <a:rPr lang="en-US" sz="1100" dirty="0">
+                <a:solidFill>
+                  <a:schemeClr val="tx1"/>
+                </a:solidFill>
+              </a:rPr>
+              <a:t>Sep 6</a:t>
+            </a:r>
+            <a:endParaRPr lang="en-US" sz="1100" dirty="0"/>
+          </a:p>
+        </p:txBody>
+      </p:sp>
+      <p:sp>
+        <p:nvSpPr>
+          <p:cNvPr id="18" name="Text 12"/>
+          <p:cNvSpPr txBox="1"/>
+          <p:nvPr/>
+        </p:nvSpPr>
+        <p:spPr>
+          <a:xfrm>
+            <a:off x="7864068" y="3954780"/>
+            <a:ext cx="822960" cy="228600"/>
+          </a:xfrm>
+          <a:prstGeom prst="rect">
+            <a:avLst/>
+          </a:prstGeom>
+          <a:noFill/>
+          <a:ln/>
+        </p:spPr>
+        <p:txBody>
+          <a:bodyPr wrap="square" lIns="0" tIns="0" rIns="0" bIns="0" rtlCol="0" anchor="t"/>
+          <a:lstStyle/>
+          <a:p>
+            <a:pPr algn="ctr" indent="0" marL="0">
+              <a:buNone/>
+            </a:pPr>
+            <a:r>
+              <a:rPr lang="en-US" sz="1100" dirty="0">
+                <a:solidFill>
+                  <a:schemeClr val="tx1"/>
+                </a:solidFill>
+              </a:rPr>
+              <a:t>Sep 15</a:t>
+            </a:r>
+            <a:endParaRPr lang="en-US" sz="1100" dirty="0"/>
+          </a:p>
+        </p:txBody>
+      </p:sp>
+      <p:sp>
+        <p:nvSpPr>
+          <p:cNvPr id="19" name="Text 13"/>
+          <p:cNvSpPr txBox="1"/>
+          <p:nvPr/>
+        </p:nvSpPr>
+        <p:spPr>
+          <a:xfrm>
+            <a:off x="9195760" y="3954780"/>
+            <a:ext cx="822960" cy="228600"/>
+          </a:xfrm>
+          <a:prstGeom prst="rect">
+            <a:avLst/>
+          </a:prstGeom>
+          <a:noFill/>
+          <a:ln/>
+        </p:spPr>
+        <p:txBody>
+          <a:bodyPr wrap="square" lIns="0" tIns="0" rIns="0" bIns="0" rtlCol="0" anchor="t"/>
+          <a:lstStyle/>
+          <a:p>
+            <a:pPr algn="ctr" indent="0" marL="0">
+              <a:buNone/>
+            </a:pPr>
+            <a:r>
+              <a:rPr lang="en-US" sz="1100" dirty="0">
+                <a:solidFill>
+                  <a:schemeClr val="tx1"/>
+                </a:solidFill>
+              </a:rPr>
+              <a:t>Sep 24</a:t>
+            </a:r>
+            <a:endParaRPr lang="en-US" sz="1100" dirty="0"/>
+          </a:p>
+        </p:txBody>
+      </p:sp>
+      <p:sp>
+        <p:nvSpPr>
+          <p:cNvPr id="20" name="Text 14"/>
+          <p:cNvSpPr txBox="1"/>
+          <p:nvPr/>
+        </p:nvSpPr>
+        <p:spPr>
+          <a:xfrm>
+            <a:off x="10823384" y="3954780"/>
+            <a:ext cx="822960" cy="228600"/>
+          </a:xfrm>
+          <a:prstGeom prst="rect">
+            <a:avLst/>
+          </a:prstGeom>
+          <a:noFill/>
+          <a:ln/>
+        </p:spPr>
+        <p:txBody>
+          <a:bodyPr wrap="square" lIns="0" tIns="0" rIns="0" bIns="0" rtlCol="0" anchor="t"/>
+          <a:lstStyle/>
+          <a:p>
+            <a:pPr algn="ctr" indent="0" marL="0">
+              <a:buNone/>
+            </a:pPr>
+            <a:r>
+              <a:rPr lang="en-US" sz="1100" dirty="0">
+                <a:solidFill>
+                  <a:schemeClr val="tx1"/>
+                </a:solidFill>
+              </a:rPr>
+              <a:t>Oct 5</a:t>
+            </a:r>
+            <a:endParaRPr lang="en-US" sz="1100" dirty="0"/>
+          </a:p>
+        </p:txBody>
+      </p:sp>
+      <p:sp>
+        <p:nvSpPr>
+          <p:cNvPr id="21" name="Text 15"/>
+          <p:cNvSpPr txBox="1"/>
+          <p:nvPr/>
+        </p:nvSpPr>
+        <p:spPr>
+          <a:xfrm>
+            <a:off x="9167497" y="2171700"/>
+            <a:ext cx="1323383" cy="228600"/>
+          </a:xfrm>
+          <a:prstGeom prst="rect">
+            <a:avLst/>
+          </a:prstGeom>
+          <a:noFill/>
+          <a:ln/>
+        </p:spPr>
+        <p:txBody>
+          <a:bodyPr wrap="square" lIns="0" tIns="0" rIns="0" bIns="0" rtlCol="0" anchor="t"/>
+          <a:lstStyle/>
+          <a:p>
+            <a:pPr algn="ctr" indent="0" marL="0">
+              <a:buNone/>
+            </a:pPr>
+            <a:r>
+              <a:rPr lang="en-US" sz="1100" b="1" dirty="0">
+                <a:solidFill>
+                  <a:schemeClr val="accent6"/>
+                </a:solidFill>
+              </a:rPr>
+              <a:t>Sep 24–27</a:t>
+            </a:r>
+            <a:endParaRPr lang="en-US" sz="1100" dirty="0"/>
+          </a:p>
+        </p:txBody>
+      </p:sp>
+      <p:sp>
+        <p:nvSpPr>
+          <p:cNvPr id="22" name="Volume fact"/>
           <p:cNvSpPr/>
           <p:nvPr/>
         </p:nvSpPr>
         <p:spPr>
           <a:xfrm>
-            <a:off x="6705317" y="4334256"/>
-            <a:ext cx="1371600" cy="384048"/>
+            <a:off x="6553048" y="4334256"/>
+            <a:ext cx="1468069" cy="603504"/>
           </a:xfrm>
           <a:prstGeom prst="roundRect">
             <a:avLst>
-              <a:gd name="adj" fmla="val 50000"/>
+              <a:gd name="adj" fmla="val 12121"/>
             </a:avLst>
           </a:prstGeom>
           <a:solidFill>
-            <a:schemeClr val="accent3"/>
+            <a:schemeClr val="bg2"/>
           </a:solidFill>
           <a:ln/>
         </p:spPr>
       </p:sp>
       <p:sp>
         <p:nvSpPr>
-          <p:cNvPr id="17" name="Text 11"/>
+          <p:cNvPr id="23" name="Text 17"/>
           <p:cNvSpPr txBox="1"/>
           <p:nvPr/>
         </p:nvSpPr>
         <p:spPr>
           <a:xfrm>
-            <a:off x="6705317" y="4334256"/>
-            <a:ext cx="1371600" cy="384048"/>
+            <a:off x="6690208" y="4334256"/>
+            <a:ext cx="1193749" cy="603504"/>
           </a:xfrm>
           <a:prstGeom prst="rect">
             <a:avLst/>
@@ -5807,53 +6657,67 @@
           <a:bodyPr wrap="square" lIns="0" tIns="0" rIns="0" bIns="0" rtlCol="0" anchor="ctr"/>
           <a:lstStyle/>
           <a:p>
-            <a:pPr algn="ctr" indent="0" marL="0">
-              <a:buNone/>
-            </a:pPr>
-            <a:r>
-              <a:rPr lang="en-US" sz="1300" b="1" dirty="0">
-                <a:solidFill>
-                  <a:schemeClr val="bg1"/>
-                </a:solidFill>
-              </a:rPr>
-              <a:t>97.4% SLA</a:t>
-            </a:r>
-            <a:endParaRPr lang="en-US" sz="1300" dirty="0"/>
-          </a:p>
-        </p:txBody>
-      </p:sp>
-      <p:sp>
-        <p:nvSpPr>
-          <p:cNvPr id="18" name="Phase 2 SLA chip"/>
+            <a:pPr indent="0" marL="0">
+              <a:buNone/>
+            </a:pPr>
+            <a:r>
+              <a:rPr lang="en-US" sz="1100" dirty="0">
+                <a:solidFill>
+                  <a:schemeClr val="accent4"/>
+                </a:solidFill>
+              </a:rPr>
+              <a:t>Volume</a:t>
+            </a:r>
+            <a:endParaRPr lang="en-US" sz="1400" dirty="0"/>
+          </a:p>
+          <a:p>
+            <a:pPr indent="0" marL="0">
+              <a:buNone/>
+            </a:pPr>
+            <a:r>
+              <a:rPr lang="en-US" sz="1400" b="1" dirty="0">
+                <a:solidFill>
+                  <a:schemeClr val="tx1"/>
+                </a:solidFill>
+              </a:rPr>
+              <a:t>95 → 89/day</a:t>
+            </a:r>
+            <a:endParaRPr lang="en-US" sz="1400" dirty="0"/>
+          </a:p>
+        </p:txBody>
+      </p:sp>
+      <p:sp>
+        <p:nvSpPr>
+          <p:cNvPr id="24" name="High-risk mix fact"/>
           <p:cNvSpPr/>
           <p:nvPr/>
         </p:nvSpPr>
         <p:spPr>
           <a:xfrm>
-            <a:off x="8252231" y="4334256"/>
-            <a:ext cx="1371600" cy="384048"/>
+            <a:off x="8203997" y="4334256"/>
+            <a:ext cx="1468069" cy="603504"/>
           </a:xfrm>
           <a:prstGeom prst="roundRect">
             <a:avLst>
-              <a:gd name="adj" fmla="val 50000"/>
+              <a:gd name="adj" fmla="val 12121"/>
             </a:avLst>
           </a:prstGeom>
           <a:solidFill>
-            <a:schemeClr val="accent6"/>
+            <a:schemeClr val="bg2"/>
           </a:solidFill>
           <a:ln/>
         </p:spPr>
       </p:sp>
       <p:sp>
         <p:nvSpPr>
-          <p:cNvPr id="19" name="Text 13"/>
+          <p:cNvPr id="25" name="Text 19"/>
           <p:cNvSpPr txBox="1"/>
           <p:nvPr/>
         </p:nvSpPr>
         <p:spPr>
           <a:xfrm>
-            <a:off x="8252231" y="4334256"/>
-            <a:ext cx="1371600" cy="384048"/>
+            <a:off x="8341157" y="4334256"/>
+            <a:ext cx="1193749" cy="603504"/>
           </a:xfrm>
           <a:prstGeom prst="rect">
             <a:avLst/>
@@ -5865,53 +6729,67 @@
           <a:bodyPr wrap="square" lIns="0" tIns="0" rIns="0" bIns="0" rtlCol="0" anchor="ctr"/>
           <a:lstStyle/>
           <a:p>
-            <a:pPr algn="ctr" indent="0" marL="0">
-              <a:buNone/>
-            </a:pPr>
-            <a:r>
-              <a:rPr lang="en-US" sz="1300" b="1" dirty="0">
-                <a:solidFill>
-                  <a:schemeClr val="bg1"/>
-                </a:solidFill>
-              </a:rPr>
-              <a:t>48.2% SLA</a:t>
-            </a:r>
-            <a:endParaRPr lang="en-US" sz="1300" dirty="0"/>
-          </a:p>
-        </p:txBody>
-      </p:sp>
-      <p:sp>
-        <p:nvSpPr>
-          <p:cNvPr id="20" name="Phase 3 SLA chip"/>
+            <a:pPr indent="0" marL="0">
+              <a:buNone/>
+            </a:pPr>
+            <a:r>
+              <a:rPr lang="en-US" sz="1100" dirty="0">
+                <a:solidFill>
+                  <a:schemeClr val="accent4"/>
+                </a:solidFill>
+              </a:rPr>
+              <a:t>High-risk mix</a:t>
+            </a:r>
+            <a:endParaRPr lang="en-US" sz="1400" dirty="0"/>
+          </a:p>
+          <a:p>
+            <a:pPr indent="0" marL="0">
+              <a:buNone/>
+            </a:pPr>
+            <a:r>
+              <a:rPr lang="en-US" sz="1400" b="1" dirty="0">
+                <a:solidFill>
+                  <a:schemeClr val="accent6"/>
+                </a:solidFill>
+              </a:rPr>
+              <a:t>24% → 43%</a:t>
+            </a:r>
+            <a:endParaRPr lang="en-US" sz="1400" dirty="0"/>
+          </a:p>
+        </p:txBody>
+      </p:sp>
+      <p:sp>
+        <p:nvSpPr>
+          <p:cNvPr id="26" name="Avg. TAT fact"/>
           <p:cNvSpPr/>
           <p:nvPr/>
         </p:nvSpPr>
         <p:spPr>
           <a:xfrm>
-            <a:off x="9799146" y="4334256"/>
-            <a:ext cx="1371600" cy="384048"/>
+            <a:off x="9854946" y="4334256"/>
+            <a:ext cx="1468069" cy="603504"/>
           </a:xfrm>
           <a:prstGeom prst="roundRect">
             <a:avLst>
-              <a:gd name="adj" fmla="val 50000"/>
+              <a:gd name="adj" fmla="val 12121"/>
             </a:avLst>
           </a:prstGeom>
           <a:solidFill>
-            <a:schemeClr val="accent4"/>
+            <a:schemeClr val="bg2"/>
           </a:solidFill>
           <a:ln/>
         </p:spPr>
       </p:sp>
       <p:sp>
         <p:nvSpPr>
-          <p:cNvPr id="21" name="Text 15"/>
+          <p:cNvPr id="27" name="Text 21"/>
           <p:cNvSpPr txBox="1"/>
           <p:nvPr/>
         </p:nvSpPr>
         <p:spPr>
           <a:xfrm>
-            <a:off x="9799146" y="4334256"/>
-            <a:ext cx="1371600" cy="384048"/>
+            <a:off x="9992106" y="4334256"/>
+            <a:ext cx="1193749" cy="603504"/>
           </a:xfrm>
           <a:prstGeom prst="rect">
             <a:avLst/>
@@ -5923,43 +6801,7 @@
           <a:bodyPr wrap="square" lIns="0" tIns="0" rIns="0" bIns="0" rtlCol="0" anchor="ctr"/>
           <a:lstStyle/>
           <a:p>
-            <a:pPr algn="ctr" indent="0" marL="0">
-              <a:buNone/>
-            </a:pPr>
-            <a:r>
-              <a:rPr lang="en-US" sz="1300" b="1" dirty="0">
-                <a:solidFill>
-                  <a:schemeClr val="bg1"/>
-                </a:solidFill>
-              </a:rPr>
-              <a:t>88.5% SLA</a:t>
-            </a:r>
-            <a:endParaRPr lang="en-US" sz="1300" dirty="0"/>
-          </a:p>
-        </p:txBody>
-      </p:sp>
-      <p:sp>
-        <p:nvSpPr>
-          <p:cNvPr id="22" name="Text 16"/>
-          <p:cNvSpPr txBox="1"/>
-          <p:nvPr/>
-        </p:nvSpPr>
-        <p:spPr>
-          <a:xfrm>
-            <a:off x="6553048" y="4773168"/>
-            <a:ext cx="4769968" cy="256032"/>
-          </a:xfrm>
-          <a:prstGeom prst="rect">
-            <a:avLst/>
-          </a:prstGeom>
-          <a:noFill/>
-          <a:ln/>
-        </p:spPr>
-        <p:txBody>
-          <a:bodyPr wrap="square" lIns="0" tIns="0" rIns="0" bIns="0" rtlCol="0" anchor="t"/>
-          <a:lstStyle/>
-          <a:p>
-            <a:pPr algn="ctr" indent="0" marL="0">
+            <a:pPr indent="0" marL="0">
               <a:buNone/>
             </a:pPr>
             <a:r>
@@ -5968,15 +6810,29 @@
                   <a:schemeClr val="accent4"/>
                 </a:solidFill>
               </a:rPr>
-              <a:t>+135% arrivals vs. an ~80/day staffing plan</a:t>
-            </a:r>
-            <a:endParaRPr lang="en-US" sz="1100" dirty="0"/>
-          </a:p>
-        </p:txBody>
-      </p:sp>
-      <p:sp>
-        <p:nvSpPr>
-          <p:cNvPr id="23" name="Wellness safeguard banner"/>
+              <a:t>Avg. TAT</a:t>
+            </a:r>
+            <a:endParaRPr lang="en-US" sz="1400" dirty="0"/>
+          </a:p>
+          <a:p>
+            <a:pPr indent="0" marL="0">
+              <a:buNone/>
+            </a:pPr>
+            <a:r>
+              <a:rPr lang="en-US" sz="1400" b="1" dirty="0">
+                <a:solidFill>
+                  <a:schemeClr val="accent6"/>
+                </a:solidFill>
+              </a:rPr>
+              <a:t>134 → 241 min</a:t>
+            </a:r>
+            <a:endParaRPr lang="en-US" sz="1400" dirty="0"/>
+          </a:p>
+        </p:txBody>
+      </p:sp>
+      <p:sp>
+        <p:nvSpPr>
+          <p:cNvPr id="28" name="Wellness safeguard banner"/>
           <p:cNvSpPr/>
           <p:nvPr/>
         </p:nvSpPr>
@@ -6005,7 +6861,7 @@
       </p:sp>
       <p:sp>
         <p:nvSpPr>
-          <p:cNvPr id="24" name="Wellness safeguard circle"/>
+          <p:cNvPr id="29" name="Wellness safeguard circle"/>
           <p:cNvSpPr/>
           <p:nvPr/>
         </p:nvSpPr>
@@ -6025,7 +6881,7 @@
       </p:sp>
       <p:pic>
         <p:nvPicPr>
-          <p:cNvPr id="25" name="Wellness safeguard icon" descr="Wellness safeguard">    </p:cNvPr>
+          <p:cNvPr id="30" name="Wellness safeguard icon" descr="Wellness safeguard">    </p:cNvPr>
           <p:cNvPicPr>
             <a:picLocks noChangeAspect="1"/>
           </p:cNvPicPr>
@@ -6049,7 +6905,7 @@
       </p:pic>
       <p:sp>
         <p:nvSpPr>
-          <p:cNvPr id="26" name="Text 19"/>
+          <p:cNvPr id="31" name="Text 24"/>
           <p:cNvSpPr txBox="1"/>
           <p:nvPr/>
         </p:nvSpPr>
@@ -6077,7 +6933,7 @@
                   <a:schemeClr val="accent2"/>
                 </a:solidFill>
               </a:rPr>
-              <a:t>719 egregious items</a:t>
+              <a:t>719 egregious items (26% of volume)</a:t>
             </a:r>
             <a:pPr indent="0" marL="0">
               <a:buNone/>
@@ -6088,7 +6944,7 @@
                   <a:schemeClr val="bg1"/>
                 </a:solidFill>
               </a:rPr>
-              <a:t> triggered mandatory 5.5-hour shift caps and 30-minute wellness rotations. Capacity cannot be recovered by extending shifts; it must be recovered by routing.</a:t>
+              <a:t> sit entirely in Violence, Hate Speech &amp; TCO and trigger 5.5-hour shift caps with 30-minute wellness rotations. Capacity cannot be recovered by extending shifts; it must be recovered by routing.</a:t>
             </a:r>
             <a:endParaRPr lang="en-US" sz="1500" dirty="0"/>
           </a:p>
@@ -6343,7 +7199,7 @@
                   <a:schemeClr val="accent1"/>
                 </a:solidFill>
               </a:rPr>
-              <a:t>Speed vs. quality by tenure cohort</a:t>
+              <a:t>Speed vs. quality: 15 agents by tenure</a:t>
             </a:r>
             <a:endParaRPr lang="en-US" sz="1600" dirty="0"/>
           </a:p>
@@ -6351,7 +7207,7 @@
       </p:sp>
       <p:graphicFrame>
         <p:nvGraphicFramePr>
-          <p:cNvPr id="8" name="Speed vs quality scatter" descr="Scatter plot of AHT versus QA score for Senior, Core and New Hire cohorts"/>
+          <p:cNvPr id="8" name="Speed vs quality scatter" descr="Scatter plot of each agent's average handling time versus audited QA score, coloured by tenure"/>
           <p:cNvGraphicFramePr/>
           <p:nvPr/>
         </p:nvGraphicFramePr>
@@ -6426,7 +7282,7 @@
                   <a:schemeClr val="accent4"/>
                 </a:solidFill>
               </a:rPr>
-              <a:t>   99.4% QA  ·  38s AHT</a:t>
+              <a:t>   99.8% QA  ·  54.0s AHT (84s on manual)</a:t>
             </a:r>
             <a:endParaRPr lang="en-US" sz="1300" dirty="0"/>
           </a:p>
@@ -6493,7 +7349,7 @@
                   <a:schemeClr val="accent4"/>
                 </a:solidFill>
               </a:rPr>
-              <a:t>   98.7% QA  ·  52s AHT</a:t>
+              <a:t>   99.2% QA  ·  48.0s AHT (97s on manual)</a:t>
             </a:r>
             <a:endParaRPr lang="en-US" sz="1300" dirty="0"/>
           </a:p>
@@ -6560,7 +7416,7 @@
                   <a:schemeClr val="accent4"/>
                 </a:solidFill>
               </a:rPr>
-              <a:t>   93.8% QA  ·  72s AHT</a:t>
+              <a:t>   94.5% QA  ·  62.7s AHT (125s on manual)</a:t>
             </a:r>
             <a:endParaRPr lang="en-US" sz="1300" dirty="0"/>
           </a:p>
@@ -6596,7 +7452,7 @@
                   <a:schemeClr val="accent4"/>
                 </a:solidFill>
               </a:rPr>
-              <a:t>Senior agents are 47% faster than new hires; new-hire errors are false negatives on nuanced hate-speech slang.</a:t>
+              <a:t>New hires made 4 of 7 audit errors (6.8% error rate vs. 1.1% tenured); 3 of the 4 were false positives.</a:t>
             </a:r>
             <a:endParaRPr lang="en-US" sz="1200" dirty="0"/>
           </a:p>
@@ -6604,7 +7460,7 @@
       </p:sp>
       <p:sp>
         <p:nvSpPr>
-          <p:cNvPr id="16" name="Erlang-C capacity card"/>
+          <p:cNvPr id="16" name="Capacity card"/>
           <p:cNvSpPr/>
           <p:nvPr/>
         </p:nvSpPr>
@@ -6633,7 +7489,7 @@
       </p:sp>
       <p:sp>
         <p:nvSpPr>
-          <p:cNvPr id="17" name="Erlang-C circle"/>
+          <p:cNvPr id="17" name="Capacity model circle"/>
           <p:cNvSpPr/>
           <p:nvPr/>
         </p:nvSpPr>
@@ -6653,7 +7509,7 @@
       </p:sp>
       <p:pic>
         <p:nvPicPr>
-          <p:cNvPr id="18" name="Erlang-C icon" descr="Erlang-C">    </p:cNvPr>
+          <p:cNvPr id="18" name="Capacity model icon" descr="Capacity model">    </p:cNvPr>
           <p:cNvPicPr>
             <a:picLocks noChangeAspect="1"/>
           </p:cNvPicPr>
@@ -6705,7 +7561,7 @@
                   <a:schemeClr val="accent1"/>
                 </a:solidFill>
               </a:rPr>
-              <a:t>Erlang-C capacity gap under surge</a:t>
+              <a:t>Capacity gap under the surge mix</a:t>
             </a:r>
             <a:endParaRPr lang="en-US" sz="1600" dirty="0"/>
           </a:p>
@@ -6913,7 +7769,7 @@
                   <a:schemeClr val="tx1"/>
                 </a:solidFill>
               </a:rPr>
-              <a:t>Steady state</a:t>
+              <a:t>Handling time per item</a:t>
             </a:r>
             <a:endParaRPr lang="en-US" sz="1300" dirty="0"/>
           </a:p>
@@ -6927,7 +7783,7 @@
                   <a:schemeClr val="accent4"/>
                 </a:solidFill>
               </a:rPr>
-              <a:t>Capacity vs. workload · +12h daily surplus</a:t>
+              <a:t>Egregious share of hours 47% → 53%</a:t>
             </a:r>
             <a:endParaRPr lang="en-US" sz="1300" dirty="0"/>
           </a:p>
@@ -6963,7 +7819,7 @@
                   <a:schemeClr val="accent1"/>
                 </a:solidFill>
               </a:rPr>
-              <a:t>72h vs. 60h</a:t>
+              <a:t>49.7s → 65.3s</a:t>
             </a:r>
             <a:endParaRPr lang="en-US" sz="1500" dirty="0"/>
           </a:p>
@@ -7000,7 +7856,7 @@
         <p:spPr>
           <a:xfrm>
             <a:off x="7635240" y="4224528"/>
-            <a:ext cx="2743200" cy="274320"/>
+            <a:ext cx="3200400" cy="274320"/>
           </a:xfrm>
           <a:prstGeom prst="rect">
             <a:avLst/>
@@ -7021,7 +7877,7 @@
                   <a:schemeClr val="tx1"/>
                 </a:solidFill>
               </a:rPr>
-              <a:t>Surge: 102h daily workload</a:t>
+              <a:t>Sep 24–27, same daily volume</a:t>
             </a:r>
             <a:endParaRPr lang="en-US" sz="1300" dirty="0"/>
           </a:p>
@@ -7113,7 +7969,7 @@
                   <a:schemeClr val="tx1"/>
                 </a:solidFill>
               </a:rPr>
-              <a:t>22 FTEs</a:t>
+              <a:t>19 FTEs</a:t>
             </a:r>
             <a:endParaRPr lang="en-US" sz="1200" dirty="0"/>
           </a:p>
@@ -7164,7 +8020,7 @@
         <p:spPr>
           <a:xfrm>
             <a:off x="8823960" y="5065776"/>
-            <a:ext cx="1080447" cy="219456"/>
+            <a:ext cx="1251044" cy="219456"/>
           </a:xfrm>
           <a:prstGeom prst="rect">
             <a:avLst/>
@@ -7183,7 +8039,7 @@
         </p:nvSpPr>
         <p:spPr>
           <a:xfrm>
-            <a:off x="9950127" y="5029200"/>
+            <a:off x="10120724" y="5029200"/>
             <a:ext cx="822960" cy="292608"/>
           </a:xfrm>
           <a:prstGeom prst="rect">
@@ -7244,7 +8100,7 @@
                 <a:ea typeface="Arial" pitchFamily="34" charset="-122"/>
                 <a:cs typeface="Arial" pitchFamily="34" charset="-120"/>
               </a:rPr>
-              <a:t>−7 FTE deficit</a:t>
+              <a:t>−4 FTE deficit</a:t>
             </a:r>
             <a:endParaRPr lang="en-US" sz="2200" dirty="0"/>
           </a:p>
@@ -7280,7 +8136,7 @@
                   <a:schemeClr val="tx1"/>
                 </a:solidFill>
               </a:rPr>
-              <a:t>34.2% simulated queue-wait probability at peak</a:t>
+              <a:t>Model assumes 15 FTEs sized to the pre-surge mix</a:t>
             </a:r>
             <a:endParaRPr lang="en-US" sz="1200" dirty="0"/>
           </a:p>
@@ -7571,7 +8427,7 @@
                   <a:schemeClr val="accent1"/>
                 </a:solidFill>
               </a:rPr>
-              <a:t>Cross-queue reallocation &amp; Erlang-C leveling</a:t>
+              <a:t>Mix-triggered cross-queue flex staffing</a:t>
             </a:r>
             <a:endParaRPr lang="en-US" sz="1700" dirty="0"/>
           </a:p>
@@ -7611,7 +8467,7 @@
                   <a:schemeClr val="tx1"/>
                 </a:solidFill>
               </a:rPr>
-              <a:t>Shift 3 FTEs from Spam &amp; Fraud into high-risk queues during peak hours (11 AM – 8 PM)</a:t>
+              <a:t>When Violence + TCO exceed 35% of daily intake, flex 4 FTEs from Spam &amp; Fraud</a:t>
             </a:r>
             <a:endParaRPr lang="en-US" sz="1400" dirty="0"/>
           </a:p>
@@ -7629,7 +8485,7 @@
                   <a:schemeClr val="tx1"/>
                 </a:solidFill>
               </a:rPr>
-              <a:t>Automate de-duplication of low-risk commercial posts to free 15 agent hours a week</a:t>
+              <a:t>Spam &amp; Fraud use 22% of handling hours and Spam is already 75% automated</a:t>
             </a:r>
             <a:endParaRPr lang="en-US" sz="1400" dirty="0"/>
           </a:p>
@@ -7774,7 +8630,7 @@
                   <a:schemeClr val="accent1"/>
                 </a:solidFill>
               </a:rPr>
-              <a:t>AI triage tuning &amp; senior video routing</a:t>
+              <a:t>Smarter video routing &amp; triage pilot</a:t>
             </a:r>
             <a:endParaRPr lang="en-US" sz="1700" dirty="0"/>
           </a:p>
@@ -7814,7 +8670,7 @@
                   <a:schemeClr val="tx1"/>
                 </a:solidFill>
               </a:rPr>
-              <a:t>Lower auto-approval threshold for verified commercial accounts from 92% to 88%</a:t>
+              <a:t>Route video &amp; live to Core and Senior agents; new hires are 20–41% slower on them</a:t>
             </a:r>
             <a:endParaRPr lang="en-US" sz="1400" dirty="0"/>
           </a:p>
@@ -7832,7 +8688,7 @@
                   <a:schemeClr val="tx1"/>
                 </a:solidFill>
               </a:rPr>
-              <a:t>Route high-risk video to senior agents (AGENT_12–15) to cut video AHT by 22%</a:t>
+              <a:t>Pilot wider auto-triage in Violence (33% automated) and TCO (24%) with QA sign-off</a:t>
             </a:r>
             <a:endParaRPr lang="en-US" sz="1400" dirty="0"/>
           </a:p>
@@ -7977,7 +8833,7 @@
                   <a:schemeClr val="accent1"/>
                 </a:solidFill>
               </a:rPr>
-              <a:t>Hate-speech calibration &amp; wellness scheduling</a:t>
+              <a:t>New-hire calibration &amp; wellness scheduling</a:t>
             </a:r>
             <a:endParaRPr lang="en-US" sz="1700" dirty="0"/>
           </a:p>
@@ -8017,7 +8873,7 @@
                   <a:schemeClr val="tx1"/>
                 </a:solidFill>
               </a:rPr>
-              <a:t>Pair new hires with senior mentors for 20-minute daily calibration on dog whistles</a:t>
+              <a:t>Daily 20-minute calibration with senior mentors on over-enforcement (false positives)</a:t>
             </a:r>
             <a:endParaRPr lang="en-US" sz="1400" dirty="0"/>
           </a:p>
@@ -8043,7 +8899,7 @@
       </p:sp>
       <p:sp>
         <p:nvSpPr>
-          <p:cNvPr id="22" name="Executive ROI banner"/>
+          <p:cNvPr id="22" name="Recovery targets banner"/>
           <p:cNvSpPr/>
           <p:nvPr/>
         </p:nvSpPr>
@@ -8171,7 +9027,7 @@
                 <a:ea typeface="Arial" pitchFamily="34" charset="-122"/>
                 <a:cs typeface="Arial" pitchFamily="34" charset="-120"/>
               </a:rPr>
-              <a:t>78.2% → ≥96.5%</a:t>
+              <a:t>78.2% → ≥95%</a:t>
             </a:r>
             <a:endParaRPr lang="en-US" sz="3000" dirty="0"/>
           </a:p>
@@ -8207,7 +9063,7 @@
                   <a:schemeClr val="tx1"/>
                 </a:solidFill>
               </a:rPr>
-              <a:t>account SLA within 14 days</a:t>
+              <a:t>account SLA target within 14 days</a:t>
             </a:r>
             <a:endParaRPr lang="en-US" sz="1400" dirty="0"/>
           </a:p>
@@ -8246,7 +9102,7 @@
                 <a:ea typeface="Arial" pitchFamily="34" charset="-122"/>
                 <a:cs typeface="Arial" pitchFamily="34" charset="-120"/>
               </a:rPr>
-              <a:t>≥98.0%</a:t>
+              <a:t>56.7% → ≥95%</a:t>
             </a:r>
             <a:endParaRPr lang="en-US" sz="3000" dirty="0"/>
           </a:p>
@@ -8282,7 +9138,7 @@
                   <a:schemeClr val="tx1"/>
                 </a:solidFill>
               </a:rPr>
-              <a:t>TCO 1-hour emergency SLA</a:t>
+              <a:t>TCO 1-hour emergency SLA target</a:t>
             </a:r>
             <a:endParaRPr lang="en-US" sz="1400" dirty="0"/>
           </a:p>
@@ -8537,7 +9393,7 @@
                   <a:schemeClr val="accent1"/>
                 </a:solidFill>
               </a:rPr>
-              <a:t>Won't Spam SLA collapse if we move 3 agents to high-risk video?</a:t>
+              <a:t>Won't Spam SLA collapse if we flex capacity out of Spam &amp; Fraud?</a:t>
             </a:r>
             <a:endParaRPr lang="en-US" sz="1600" dirty="0"/>
           </a:p>
@@ -8573,7 +9429,7 @@
                   <a:schemeClr val="tx1"/>
                 </a:solidFill>
               </a:rPr>
-              <a:t>No. Spam runs at 12.3s AHT and 96.4% SLA with 75% automated triage. The capacity model holds Spam at 94.5% SLA with 3 fewer FTEs, while those agents add 45 hours of relief to breached video queues.</a:t>
+              <a:t>Unlikely. Spam runs at 12.3s AHT and 96.4% SLA with 75% of items automated, and Spam &amp; Fraud together use only 22% of handling hours. Flexing is triggered only on high-risk mix days.</a:t>
             </a:r>
             <a:endParaRPr lang="en-US" sz="1400" dirty="0"/>
           </a:p>
@@ -8682,7 +9538,7 @@
                   <a:schemeClr val="accent1"/>
                 </a:solidFill>
               </a:rPr>
-              <a:t>Why not mandate 8-hour shifts for all agents to clear the backlog?</a:t>
+              <a:t>Why not mandate 8-hour shifts for everyone to clear the backlog?</a:t>
             </a:r>
             <a:endParaRPr lang="en-US" sz="1600" dirty="0"/>
           </a:p>
@@ -8718,7 +9574,7 @@
                   <a:schemeClr val="tx1"/>
                 </a:solidFill>
               </a:rPr>
-              <a:t>It breaches duty-of-care guidelines. Beyond 2 consecutive hours in egregious queues, false negatives rise 40%. The 5.5h cap with rotation protects 98.6% accuracy and limits attrition.</a:t>
+              <a:t>All 719 egregious items sit in the high-risk queues, and duty-of-care caps exposure at 5.5 hours. Violence QA already dipped to 88.9% during the surge (9 audits). Rotation protects accuracy.</a:t>
             </a:r>
             <a:endParaRPr lang="en-US" sz="1400" dirty="0"/>
           </a:p>
@@ -8827,7 +9683,7 @@
                   <a:schemeClr val="accent1"/>
                 </a:solidFill>
               </a:rPr>
-              <a:t>How does lowering the triage threshold from 92% to 88% affect false positives?</a:t>
+              <a:t>Does widening automated triage risk more false positives?</a:t>
             </a:r>
             <a:endParaRPr lang="en-US" sz="1600" dirty="0"/>
           </a:p>
@@ -8863,7 +9719,7 @@
                   <a:schemeClr val="tx1"/>
                 </a:solidFill>
               </a:rPr>
-              <a:t>Back-tested on historical audit logs: +0.08% false-positive risk on Commercial Spam, well within the 2.0% tolerance. Disputed removals go through appeals, which already overturn only 15.8%.</a:t>
+              <a:t>We pilot with QA sign-off. Today auto-approved items audit at 100% (75 audits) and auto-rejected at 97.3% (81 audits), and appeals overturn only 15.8% of disputed decisions.</a:t>
             </a:r>
             <a:endParaRPr lang="en-US" sz="1400" dirty="0"/>
           </a:p>

</xml_diff>

<commit_message>
docs: fix deck repair error and sync outline with the data-driven deck
The speed-vs-quality scatter chart stored series gaps as empty <c:v>
values, which PowerPoint treats as a corrupt chart and fails to repair.
Gaps are now omitted points, the valid OOXML form.

PRESENTATION_OUTLINE.md now matches the rebuilt deck: CSV-derived
figures, the Sep 24-27 mix-shift diagnosis, the 4-FTE capacity gap,
revised actions, targets and Q&A, and the backup slide.

Co-Authored-By: Claude Opus 5.5 <noreply@anthropic.com>
Claude-Session: https://claude.ai/code/session_018U5KYsVR1k6QhPhM8y4R3g
</commit_message>
<xml_diff>
--- a/docs/presentation/ApexTrust_Content_Moderation_Executive_Briefing.pptx
+++ b/docs/presentation/ApexTrust_Content_Moderation_Executive_Briefing.pptx
@@ -112,28 +112,28 @@
   <p:extLst>
     <p:ext uri="{521415D9-36F7-43E2-AB2F-B90AF26B5E84}">
       <p14:sectionLst xmlns:p14="http://schemas.microsoft.com/office/powerpoint/2010/main">
-        <p14:section name="Bottom Line Up Front" id="{9229cc15-7323-0bdb-bc1b-1d781536a0b7}">
+        <p14:section name="Bottom Line Up Front" id="{8b09b5fc-a4a9-9095-f8a8-33a4866a8549}">
           <p14:sldIdLst>
             <p14:sldId id="256"/>
           </p14:sldIdLst>
         </p14:section>
-        <p14:section name="What?" id="{0ae2e285-cb90-8f2b-6103-1837450968da}">
+        <p14:section name="What?" id="{956aad0a-e030-4ded-f504-689a6c93e0c8}">
           <p14:sldIdLst>
             <p14:sldId id="257"/>
           </p14:sldIdLst>
         </p14:section>
-        <p14:section name="So What?" id="{a032e58d-f481-5009-39bb-d346c099750a}">
+        <p14:section name="So What?" id="{b37083e4-a322-0846-9fe9-57ba70413352}">
           <p14:sldIdLst>
             <p14:sldId id="258"/>
             <p14:sldId id="259"/>
           </p14:sldIdLst>
         </p14:section>
-        <p14:section name="Now What?" id="{bf2a3e70-fe64-808c-a0e7-f3cace16e9f7}">
+        <p14:section name="Now What?" id="{c0d0ed76-29e6-f92c-5f07-f2ed53838b26}">
           <p14:sldIdLst>
             <p14:sldId id="260"/>
           </p14:sldIdLst>
         </p14:section>
-        <p14:section name="Appendix" id="{0cf4be7b-3695-73ca-b4c3-36bc20fddfe5}">
+        <p14:section name="Appendix" id="{4b95ceaa-7d97-9e5b-0652-4212d0e97798}">
           <p14:sldIdLst>
             <p14:sldId id="261"/>
           </p14:sldIdLst>
@@ -1552,39 +1552,6 @@
               <c:numCache>
                 <c:formatCode>General</c:formatCode>
                 <c:ptCount val="15"/>
-                <c:pt idx="0">
-                  <c:v/>
-                </c:pt>
-                <c:pt idx="1">
-                  <c:v/>
-                </c:pt>
-                <c:pt idx="2">
-                  <c:v/>
-                </c:pt>
-                <c:pt idx="3">
-                  <c:v/>
-                </c:pt>
-                <c:pt idx="4">
-                  <c:v/>
-                </c:pt>
-                <c:pt idx="5">
-                  <c:v/>
-                </c:pt>
-                <c:pt idx="6">
-                  <c:v/>
-                </c:pt>
-                <c:pt idx="7">
-                  <c:v/>
-                </c:pt>
-                <c:pt idx="8">
-                  <c:v/>
-                </c:pt>
-                <c:pt idx="9">
-                  <c:v/>
-                </c:pt>
-                <c:pt idx="10">
-                  <c:v/>
-                </c:pt>
                 <c:pt idx="11">
                   <c:v>100</c:v>
                 </c:pt>
@@ -1702,15 +1669,6 @@
               <c:numCache>
                 <c:formatCode>General</c:formatCode>
                 <c:ptCount val="15"/>
-                <c:pt idx="0">
-                  <c:v/>
-                </c:pt>
-                <c:pt idx="1">
-                  <c:v/>
-                </c:pt>
-                <c:pt idx="2">
-                  <c:v/>
-                </c:pt>
                 <c:pt idx="3">
                   <c:v>99.2</c:v>
                 </c:pt>
@@ -1734,18 +1692,6 @@
                 </c:pt>
                 <c:pt idx="10">
                   <c:v>100</c:v>
-                </c:pt>
-                <c:pt idx="11">
-                  <c:v/>
-                </c:pt>
-                <c:pt idx="12">
-                  <c:v/>
-                </c:pt>
-                <c:pt idx="13">
-                  <c:v/>
-                </c:pt>
-                <c:pt idx="14">
-                  <c:v/>
                 </c:pt>
               </c:numCache>
             </c:numRef>
@@ -1860,42 +1806,6 @@
                 </c:pt>
                 <c:pt idx="2">
                   <c:v>91.7</c:v>
-                </c:pt>
-                <c:pt idx="3">
-                  <c:v/>
-                </c:pt>
-                <c:pt idx="4">
-                  <c:v/>
-                </c:pt>
-                <c:pt idx="5">
-                  <c:v/>
-                </c:pt>
-                <c:pt idx="6">
-                  <c:v/>
-                </c:pt>
-                <c:pt idx="7">
-                  <c:v/>
-                </c:pt>
-                <c:pt idx="8">
-                  <c:v/>
-                </c:pt>
-                <c:pt idx="9">
-                  <c:v/>
-                </c:pt>
-                <c:pt idx="10">
-                  <c:v/>
-                </c:pt>
-                <c:pt idx="11">
-                  <c:v/>
-                </c:pt>
-                <c:pt idx="12">
-                  <c:v/>
-                </c:pt>
-                <c:pt idx="13">
-                  <c:v/>
-                </c:pt>
-                <c:pt idx="14">
-                  <c:v/>
                 </c:pt>
               </c:numCache>
             </c:numRef>

</xml_diff>

<commit_message>
docs: fix PowerPoint dropping slide 3 of the executive briefing
The daily SLA line chart was written with <a:prstDash val="solid,dash"/>,
an illegal dash value, so PowerPoint could not read the chart and its
repair removed the whole Root Cause slide. Each series now carries a
single legal dash (solid SLA line, dashed 95% target).

Co-Authored-By: Claude Opus 5.5 <noreply@anthropic.com>
Claude-Session: https://claude.ai/code/session_018U5KYsVR1k6QhPhM8y4R3g
</commit_message>
<xml_diff>
--- a/docs/presentation/ApexTrust_Content_Moderation_Executive_Briefing.pptx
+++ b/docs/presentation/ApexTrust_Content_Moderation_Executive_Briefing.pptx
@@ -112,28 +112,28 @@
   <p:extLst>
     <p:ext uri="{521415D9-36F7-43E2-AB2F-B90AF26B5E84}">
       <p14:sectionLst xmlns:p14="http://schemas.microsoft.com/office/powerpoint/2010/main">
-        <p14:section name="Bottom Line Up Front" id="{8b09b5fc-a4a9-9095-f8a8-33a4866a8549}">
+        <p14:section name="Bottom Line Up Front" id="{6268cab0-1c7a-727b-70f2-298886724c1d}">
           <p14:sldIdLst>
             <p14:sldId id="256"/>
           </p14:sldIdLst>
         </p14:section>
-        <p14:section name="What?" id="{956aad0a-e030-4ded-f504-689a6c93e0c8}">
+        <p14:section name="What?" id="{ae74072d-40eb-3a59-cc09-c90373aefa57}">
           <p14:sldIdLst>
             <p14:sldId id="257"/>
           </p14:sldIdLst>
         </p14:section>
-        <p14:section name="So What?" id="{b37083e4-a322-0846-9fe9-57ba70413352}">
+        <p14:section name="So What?" id="{8312f636-90ad-e39a-f491-997c48fdeb27}">
           <p14:sldIdLst>
             <p14:sldId id="258"/>
             <p14:sldId id="259"/>
           </p14:sldIdLst>
         </p14:section>
-        <p14:section name="Now What?" id="{c0d0ed76-29e6-f92c-5f07-f2ed53838b26}">
+        <p14:section name="Now What?" id="{d40ad9a0-e9af-4ecf-fa9b-5a05dd8e79b8}">
           <p14:sldIdLst>
             <p14:sldId id="260"/>
           </p14:sldIdLst>
         </p14:section>
-        <p14:section name="Appendix" id="{4b95ceaa-7d97-9e5b-0652-4212d0e97798}">
+        <p14:section name="Appendix" id="{4458faef-d0b6-a919-bfff-cde6ebb6bd4b}">
           <p14:sldIdLst>
             <p14:sldId id="261"/>
           </p14:sldIdLst>
@@ -776,7 +776,7 @@
               <a:solidFill>
                 <a:srgbClr val="492C73"/>
               </a:solidFill>
-              <a:prstDash val="solid,dash"/>
+              <a:prstDash val="solid"/>
               <a:round/>
             </a:ln>
             <a:effectLst/>
@@ -1046,7 +1046,7 @@
               <a:solidFill>
                 <a:srgbClr val="74BF04"/>
               </a:solidFill>
-              <a:prstDash val="solid,dash"/>
+              <a:prstDash val="dash"/>
               <a:round/>
             </a:ln>
             <a:effectLst/>

</xml_diff>